<commit_message>
perf(api): compute and store SHAP values selectively for suspicious transactions only
</commit_message>
<xml_diff>
--- a/presentation.pptx
+++ b/presentation.pptx
@@ -15564,6 +15564,11 @@
               <a:rPr dirty="0"/>
               <a:t>.</a:t>
             </a:r>
+            <a:r>
+              <a:rPr lang="fr-FR" dirty="0"/>
+              <a:t> </a:t>
+            </a:r>
+            <a:endParaRPr dirty="0"/>
           </a:p>
         </p:txBody>
       </p:sp>
@@ -15829,6 +15834,50 @@
                 <a:latin typeface="Segoe UI"/>
               </a:defRPr>
             </a:pPr>
+            <a:r>
+              <a:rPr lang="fr-FR" dirty="0"/>
+              <a:t>• Minimisation du stockage des valeurs de </a:t>
+            </a:r>
+            <a:r>
+              <a:rPr lang="fr-FR" dirty="0" err="1"/>
+              <a:t>shap</a:t>
+            </a:r>
+            <a:r>
+              <a:rPr lang="fr-FR" dirty="0"/>
+              <a:t>  UNIQUEMENT pour les </a:t>
+            </a:r>
+            <a:r>
+              <a:rPr lang="fr-FR"/>
+              <a:t>transactions frauduleuses</a:t>
+            </a:r>
+            <a:endParaRPr lang="fr-FR" dirty="0"/>
+          </a:p>
+          <a:p>
+            <a:pPr>
+              <a:spcAft>
+                <a:spcPts val="0"/>
+              </a:spcAft>
+              <a:defRPr sz="1200" b="0">
+                <a:solidFill>
+                  <a:srgbClr val="475569"/>
+                </a:solidFill>
+                <a:latin typeface="Segoe UI"/>
+              </a:defRPr>
+            </a:pPr>
+            <a:endParaRPr lang="fr-FR" dirty="0"/>
+          </a:p>
+          <a:p>
+            <a:pPr>
+              <a:spcAft>
+                <a:spcPts val="0"/>
+              </a:spcAft>
+              <a:defRPr sz="1200" b="0">
+                <a:solidFill>
+                  <a:srgbClr val="475569"/>
+                </a:solidFill>
+                <a:latin typeface="Segoe UI"/>
+              </a:defRPr>
+            </a:pPr>
             <a:endParaRPr lang="fr-FR" sz="800" dirty="0"/>
           </a:p>
           <a:p>
@@ -16293,24 +16342,21 @@
             </a:pPr>
             <a:r>
               <a:rPr dirty="0"/>
-              <a:t>• Stockage </a:t>
-            </a:r>
-            <a:r>
-              <a:rPr lang="fr-FR" dirty="0"/>
-              <a:t>des KPI de fraudes (</a:t>
+              <a:t>• S</a:t>
+            </a:r>
+            <a:r>
+              <a:rPr lang="fr-FR" dirty="0" err="1"/>
+              <a:t>euils</a:t>
+            </a:r>
+            <a:r>
+              <a:rPr lang="fr-FR" dirty="0"/>
+              <a:t> de fraude calculés par les valeurs de </a:t>
             </a:r>
             <a:r>
               <a:rPr lang="fr-FR" dirty="0" err="1"/>
               <a:t>shap</a:t>
             </a:r>
-            <a:r>
-              <a:rPr lang="fr-FR" dirty="0"/>
-              <a:t> values)</a:t>
-            </a:r>
-            <a:r>
-              <a:rPr dirty="0"/>
-              <a:t>.</a:t>
-            </a:r>
+            <a:endParaRPr dirty="0"/>
           </a:p>
           <a:p>
             <a:pPr>

</xml_diff>

<commit_message>
docs: add regulatory compliance and security section to README
</commit_message>
<xml_diff>
--- a/presentation.pptx
+++ b/presentation.pptx
@@ -5,7 +5,7 @@
     <p:sldMasterId id="2147483648" r:id="rId1"/>
   </p:sldMasterIdLst>
   <p:notesMasterIdLst>
-    <p:notesMasterId r:id="rId22"/>
+    <p:notesMasterId r:id="rId23"/>
   </p:notesMasterIdLst>
   <p:sldIdLst>
     <p:sldId id="256" r:id="rId2"/>
@@ -25,9 +25,10 @@
     <p:sldId id="310" r:id="rId16"/>
     <p:sldId id="303" r:id="rId17"/>
     <p:sldId id="257" r:id="rId18"/>
-    <p:sldId id="304" r:id="rId19"/>
-    <p:sldId id="305" r:id="rId20"/>
-    <p:sldId id="306" r:id="rId21"/>
+    <p:sldId id="311" r:id="rId19"/>
+    <p:sldId id="304" r:id="rId20"/>
+    <p:sldId id="305" r:id="rId21"/>
+    <p:sldId id="306" r:id="rId22"/>
   </p:sldIdLst>
   <p:sldSz cx="12192000" cy="6858000"/>
   <p:notesSz cx="6858000" cy="9144000"/>
@@ -2808,7 +2809,7 @@
         <p:cNvPr id="1" name="">
           <a:extLst>
             <a:ext uri="{FF2B5EF4-FFF2-40B4-BE49-F238E27FC236}">
-              <a16:creationId xmlns:a16="http://schemas.microsoft.com/office/drawing/2014/main" id="{468B47B6-40BB-2A57-A91F-3D047A443379}"/>
+              <a16:creationId xmlns:a16="http://schemas.microsoft.com/office/drawing/2014/main" id="{99F9C2B8-3DA2-BDEB-2DA0-7B892DCA8019}"/>
             </a:ext>
           </a:extLst>
         </p:cNvPr>
@@ -2828,7 +2829,7 @@
           <p:cNvPr id="2" name="Slide Image Placeholder 1">
             <a:extLst>
               <a:ext uri="{FF2B5EF4-FFF2-40B4-BE49-F238E27FC236}">
-                <a16:creationId xmlns:a16="http://schemas.microsoft.com/office/drawing/2014/main" id="{BED7CBD1-7C81-20D9-72D0-5A15E06F2074}"/>
+                <a16:creationId xmlns:a16="http://schemas.microsoft.com/office/drawing/2014/main" id="{A2F2B6F5-F7A8-2F21-7290-6DCED8DE7727}"/>
               </a:ext>
             </a:extLst>
           </p:cNvPr>
@@ -2846,7 +2847,7 @@
           <p:cNvPr id="3" name="Notes Placeholder 2">
             <a:extLst>
               <a:ext uri="{FF2B5EF4-FFF2-40B4-BE49-F238E27FC236}">
-                <a16:creationId xmlns:a16="http://schemas.microsoft.com/office/drawing/2014/main" id="{9C233E3D-F6A4-FF30-07A0-A5FB266F146E}"/>
+                <a16:creationId xmlns:a16="http://schemas.microsoft.com/office/drawing/2014/main" id="{8E30A928-9CF2-3C98-1BD3-54D327AAFBD0}"/>
               </a:ext>
             </a:extLst>
           </p:cNvPr>
@@ -3284,7 +3285,7 @@
           <p:cNvPr id="4" name="Slide Number Placeholder 3">
             <a:extLst>
               <a:ext uri="{FF2B5EF4-FFF2-40B4-BE49-F238E27FC236}">
-                <a16:creationId xmlns:a16="http://schemas.microsoft.com/office/drawing/2014/main" id="{C3FB8016-F3D0-C2E9-664F-ACAF1D20A16A}"/>
+                <a16:creationId xmlns:a16="http://schemas.microsoft.com/office/drawing/2014/main" id="{324BA956-623D-7231-1F59-B9175A05D2E6}"/>
               </a:ext>
             </a:extLst>
           </p:cNvPr>
@@ -3300,7 +3301,7 @@
     </p:spTree>
     <p:extLst>
       <p:ext uri="{BB962C8B-B14F-4D97-AF65-F5344CB8AC3E}">
-        <p14:creationId xmlns:p14="http://schemas.microsoft.com/office/powerpoint/2010/main" val="1194679795"/>
+        <p14:creationId xmlns:p14="http://schemas.microsoft.com/office/powerpoint/2010/main" val="1963766993"/>
       </p:ext>
     </p:extLst>
   </p:cSld>
@@ -3318,7 +3319,7 @@
         <p:cNvPr id="1" name="">
           <a:extLst>
             <a:ext uri="{FF2B5EF4-FFF2-40B4-BE49-F238E27FC236}">
-              <a16:creationId xmlns:a16="http://schemas.microsoft.com/office/drawing/2014/main" id="{C4874203-273A-E073-E960-A9FC0B486E64}"/>
+              <a16:creationId xmlns:a16="http://schemas.microsoft.com/office/drawing/2014/main" id="{468B47B6-40BB-2A57-A91F-3D047A443379}"/>
             </a:ext>
           </a:extLst>
         </p:cNvPr>
@@ -3338,7 +3339,7 @@
           <p:cNvPr id="2" name="Slide Image Placeholder 1">
             <a:extLst>
               <a:ext uri="{FF2B5EF4-FFF2-40B4-BE49-F238E27FC236}">
-                <a16:creationId xmlns:a16="http://schemas.microsoft.com/office/drawing/2014/main" id="{0E86EA60-FF27-4F6E-4DEA-A7A8913CD857}"/>
+                <a16:creationId xmlns:a16="http://schemas.microsoft.com/office/drawing/2014/main" id="{BED7CBD1-7C81-20D9-72D0-5A15E06F2074}"/>
               </a:ext>
             </a:extLst>
           </p:cNvPr>
@@ -3356,7 +3357,7 @@
           <p:cNvPr id="3" name="Notes Placeholder 2">
             <a:extLst>
               <a:ext uri="{FF2B5EF4-FFF2-40B4-BE49-F238E27FC236}">
-                <a16:creationId xmlns:a16="http://schemas.microsoft.com/office/drawing/2014/main" id="{C58A4D2F-3122-A73A-7AA6-837D27C2911A}"/>
+                <a16:creationId xmlns:a16="http://schemas.microsoft.com/office/drawing/2014/main" id="{9C233E3D-F6A4-FF30-07A0-A5FB266F146E}"/>
               </a:ext>
             </a:extLst>
           </p:cNvPr>
@@ -3399,31 +3400,7 @@
                 <a:ea typeface="+mn-ea"/>
                 <a:cs typeface="+mn-cs"/>
               </a:rPr>
-              <a:t>Le cycle de développement suit les principes modernes du DevOps et du </a:t>
-            </a:r>
-            <a:r>
-              <a:rPr lang="fr-FR" sz="1200" b="0" kern="1200" dirty="0" err="1">
-                <a:solidFill>
-                  <a:schemeClr val="tx1"/>
-                </a:solidFill>
-                <a:effectLst/>
-                <a:latin typeface="+mn-lt"/>
-                <a:ea typeface="+mn-ea"/>
-                <a:cs typeface="+mn-cs"/>
-              </a:rPr>
-              <a:t>MLOps</a:t>
-            </a:r>
-            <a:r>
-              <a:rPr lang="fr-FR" sz="1200" b="0" kern="1200" dirty="0">
-                <a:solidFill>
-                  <a:schemeClr val="tx1"/>
-                </a:solidFill>
-                <a:effectLst/>
-                <a:latin typeface="+mn-lt"/>
-                <a:ea typeface="+mn-ea"/>
-                <a:cs typeface="+mn-cs"/>
-              </a:rPr>
-              <a:t>. </a:t>
+              <a:t>Notre infrastructure est bâtie pour être tolérante aux pannes. </a:t>
             </a:r>
           </a:p>
           <a:p>
@@ -3454,7 +3431,7 @@
                 <a:ea typeface="+mn-ea"/>
                 <a:cs typeface="+mn-cs"/>
               </a:rPr>
-              <a:t>La CI valide la syntaxe avec Ruff et exécute les tests unitaires avec </a:t>
+              <a:t>Si un service comme </a:t>
             </a:r>
             <a:r>
               <a:rPr lang="fr-FR" sz="1200" b="0" kern="1200" dirty="0" err="1">
@@ -3466,7 +3443,7 @@
                 <a:ea typeface="+mn-ea"/>
                 <a:cs typeface="+mn-cs"/>
               </a:rPr>
-              <a:t>Pytest</a:t>
+              <a:t>Postgres</a:t>
             </a:r>
             <a:r>
               <a:rPr lang="fr-FR" sz="1200" b="0" kern="1200" dirty="0">
@@ -3478,7 +3455,7 @@
                 <a:ea typeface="+mn-ea"/>
                 <a:cs typeface="+mn-cs"/>
               </a:rPr>
-              <a:t> à chaque mise à jour.</a:t>
+              <a:t> ou Ray s'arrête, la file d'attente locale conserve les données en toute sécurité. </a:t>
             </a:r>
           </a:p>
           <a:p>
@@ -3509,7 +3486,7 @@
                 <a:ea typeface="+mn-ea"/>
                 <a:cs typeface="+mn-cs"/>
               </a:rPr>
-              <a:t> La CD assure la portabilité via Docker. Enfin, nous introduisons le CT — le </a:t>
+              <a:t>De plus, notre architecture multi-services conteneurisée sous Docker permet de basculer facilement vers des services cloud hautement disponibles comme </a:t>
             </a:r>
             <a:r>
               <a:rPr lang="fr-FR" sz="1200" b="0" kern="1200" dirty="0" err="1">
@@ -3521,7 +3498,7 @@
                 <a:ea typeface="+mn-ea"/>
                 <a:cs typeface="+mn-cs"/>
               </a:rPr>
-              <a:t>Continuous</a:t>
+              <a:t>Kubernetes</a:t>
             </a:r>
             <a:r>
               <a:rPr lang="fr-FR" sz="1200" b="0" kern="1200" dirty="0">
@@ -3533,49 +3510,38 @@
                 <a:ea typeface="+mn-ea"/>
                 <a:cs typeface="+mn-cs"/>
               </a:rPr>
-              <a:t> Training : le système monitore en permanence les données et s'auto-corrige en déclenchant un réentraînement s'il détecte une dérive du modèle.</a:t>
-            </a:r>
-          </a:p>
-          <a:p>
-            <a:r>
-              <a:rPr lang="fr-FR" dirty="0"/>
-              <a:t> • Sur la CI (Qualité et Robustesse) :</a:t>
-            </a:r>
-          </a:p>
-          <a:p>
-            <a:r>
-              <a:rPr lang="fr-FR" dirty="0"/>
-              <a:t>  │ "Pour la partie Intégration Continue, nous avons mis en place des tests automatisés avec </a:t>
-            </a:r>
-            <a:r>
-              <a:rPr lang="fr-FR" dirty="0" err="1"/>
-              <a:t>pytest</a:t>
-            </a:r>
-            <a:r>
-              <a:rPr lang="fr-FR" dirty="0"/>
-              <a:t> et un contrôle de style strict avec </a:t>
-            </a:r>
-            <a:r>
-              <a:rPr lang="fr-FR" dirty="0" err="1"/>
-              <a:t>ruff</a:t>
-            </a:r>
-            <a:r>
-              <a:rPr lang="fr-FR" dirty="0"/>
-              <a:t>. Cela garantit que chaque modification de</a:t>
-            </a:r>
-          </a:p>
-          <a:p>
-            <a:r>
-              <a:rPr lang="fr-FR" dirty="0"/>
-              <a:t>  │ code (par exemple un nouveau calcul de </a:t>
-            </a:r>
-            <a:r>
-              <a:rPr lang="fr-FR" dirty="0" err="1"/>
-              <a:t>feature</a:t>
-            </a:r>
-            <a:r>
-              <a:rPr lang="fr-FR" dirty="0"/>
-              <a:t> pour détecter la fraude) ne casse pas le comportement existant du pipeline et respecte les standards de qualité de production."</a:t>
+              <a:t>. </a:t>
+            </a:r>
+          </a:p>
+          <a:p>
+            <a:pPr marL="0" marR="0" lvl="0" indent="0" algn="l" defTabSz="914400" rtl="0" eaLnBrk="1" fontAlgn="auto" latinLnBrk="0" hangingPunct="1">
+              <a:lnSpc>
+                <a:spcPct val="100000"/>
+              </a:lnSpc>
+              <a:spcBef>
+                <a:spcPts val="0"/>
+              </a:spcBef>
+              <a:spcAft>
+                <a:spcPts val="0"/>
+              </a:spcAft>
+              <a:buClrTx/>
+              <a:buSzTx/>
+              <a:buFontTx/>
+              <a:buNone/>
+              <a:tabLst/>
+              <a:defRPr/>
+            </a:pPr>
+            <a:r>
+              <a:rPr lang="fr-FR" sz="1200" b="0" kern="1200" dirty="0">
+                <a:solidFill>
+                  <a:schemeClr val="tx1"/>
+                </a:solidFill>
+                <a:effectLst/>
+                <a:latin typeface="+mn-lt"/>
+                <a:ea typeface="+mn-ea"/>
+                <a:cs typeface="+mn-cs"/>
+              </a:rPr>
+              <a:t>Le chiffrement HTTPS et l'anonymisation des numéros de cartes de crédit assurent par ailleurs la conformité RGPD.</a:t>
             </a:r>
           </a:p>
           <a:p>
@@ -3584,13 +3550,37 @@
           <a:p>
             <a:r>
               <a:rPr lang="fr-FR" dirty="0"/>
-              <a:t>  • Sur la CD (Déploiement Reproductible) :</a:t>
-            </a:r>
-          </a:p>
-          <a:p>
-            <a:r>
-              <a:rPr lang="fr-FR" dirty="0"/>
-              <a:t>  │ "Le déploiement s'appuie entièrement sur Docker. L'utilisation d'images Docker dédiées pour Ray, </a:t>
+              <a:t>  </a:t>
+            </a:r>
+          </a:p>
+          <a:p>
+            <a:endParaRPr lang="fr-FR" dirty="0"/>
+          </a:p>
+          <a:p>
+            <a:r>
+              <a:rPr lang="fr-FR" dirty="0"/>
+              <a:t>### 1. Ingestion continue sans perte de données, même en cas de panne de base de données</a:t>
+            </a:r>
+          </a:p>
+          <a:p>
+            <a:endParaRPr lang="fr-FR" dirty="0"/>
+          </a:p>
+          <a:p>
+            <a:r>
+              <a:rPr lang="fr-FR" dirty="0"/>
+              <a:t>  • Mécanisme de Queue Tampon (Buffer) : Les fichiers CSV bruts arrivent d'abord dans un dossier de transit (./data/queue). Ce dossier agit comme une file d'attente physique (Buffer).</a:t>
+            </a:r>
+          </a:p>
+          <a:p>
+            <a:r>
+              <a:rPr lang="fr-FR" dirty="0"/>
+              <a:t>  • Séparation Ingestion / Enregistrement : L'ingestion physique (le dépôt des fichiers) est indépendante de l'écriture en base de données.</a:t>
+            </a:r>
+          </a:p>
+          <a:p>
+            <a:r>
+              <a:rPr lang="fr-FR" dirty="0"/>
+              <a:t>  • Résilience d'</a:t>
             </a:r>
             <a:r>
               <a:rPr lang="fr-FR" dirty="0" err="1"/>
@@ -3598,7 +3588,189 @@
             </a:r>
             <a:r>
               <a:rPr lang="fr-FR" dirty="0"/>
-              <a:t> et </a:t>
+              <a:t> (Retries) : Si la base de données PostgreSQL tombe, la tâche dag_pipeline.py:45 échoue, mais les fichiers CSV restent en sécurité dans ./data/queue. Ils ne sont</a:t>
+            </a:r>
+          </a:p>
+          <a:p>
+            <a:r>
+              <a:rPr lang="fr-FR" dirty="0"/>
+              <a:t>  supprimés par dag_pipeline.py:172 qu'une fois que la prédiction a été jouée et enregistrée avec succès. Au redémarrage de la base, </a:t>
+            </a:r>
+            <a:r>
+              <a:rPr lang="fr-FR" dirty="0" err="1"/>
+              <a:t>Airflow</a:t>
+            </a:r>
+            <a:r>
+              <a:rPr lang="fr-FR" dirty="0"/>
+              <a:t> reprend là où il s'est arrêté (mécanisme de</a:t>
+            </a:r>
+          </a:p>
+          <a:p>
+            <a:r>
+              <a:rPr lang="fr-FR" dirty="0"/>
+              <a:t>  reprise sur panne/retries automatique).</a:t>
+            </a:r>
+          </a:p>
+          <a:p>
+            <a:r>
+              <a:rPr lang="fr-FR" dirty="0"/>
+              <a:t>  ──────</a:t>
+            </a:r>
+          </a:p>
+          <a:p>
+            <a:r>
+              <a:rPr lang="fr-FR" dirty="0"/>
+              <a:t>  ### 2. Absorption fluide des charges transactionnelles de pointe</a:t>
+            </a:r>
+          </a:p>
+          <a:p>
+            <a:endParaRPr lang="fr-FR" dirty="0"/>
+          </a:p>
+          <a:p>
+            <a:r>
+              <a:rPr lang="fr-FR" dirty="0"/>
+              <a:t>  • Calcul Distribué avec Ray : L'inférence lourde n'est pas traitée par le serveur web d'</a:t>
+            </a:r>
+            <a:r>
+              <a:rPr lang="fr-FR" dirty="0" err="1"/>
+              <a:t>Airflow</a:t>
+            </a:r>
+            <a:r>
+              <a:rPr lang="fr-FR" dirty="0"/>
+              <a:t> (qui saturerait vite), mais déportée sur un cluster Ray capable de paralléliser les</a:t>
+            </a:r>
+          </a:p>
+          <a:p>
+            <a:r>
+              <a:rPr lang="fr-FR" dirty="0"/>
+              <a:t>  calculs.</a:t>
+            </a:r>
+          </a:p>
+          <a:p>
+            <a:r>
+              <a:rPr lang="fr-FR" dirty="0"/>
+              <a:t>  • Traitement par Lots Limités (</a:t>
+            </a:r>
+            <a:r>
+              <a:rPr lang="fr-FR" dirty="0" err="1"/>
+              <a:t>Batching</a:t>
+            </a:r>
+            <a:r>
+              <a:rPr lang="fr-FR" dirty="0"/>
+              <a:t>) : Le DAG limite le traitement à des paquets de maximum 100 fichiers à la fois (</a:t>
+            </a:r>
+            <a:r>
+              <a:rPr lang="fr-FR" dirty="0" err="1"/>
+              <a:t>batch_size</a:t>
+            </a:r>
+            <a:r>
+              <a:rPr lang="fr-FR" dirty="0"/>
+              <a:t> = 100 dans dag_pipeline.py:54). Si 10 000 fichiers</a:t>
+            </a:r>
+          </a:p>
+          <a:p>
+            <a:r>
+              <a:rPr lang="fr-FR" dirty="0"/>
+              <a:t>  arrivent d'un coup suite à une pointe, ils ne saturent pas la mémoire : ils sont traités de manière fluide, lot par lot.</a:t>
+            </a:r>
+          </a:p>
+          <a:p>
+            <a:r>
+              <a:rPr lang="fr-FR" dirty="0"/>
+              <a:t>  • GPU NVIDIA : Le Ray Worker dispose d'un GPU (driver: </a:t>
+            </a:r>
+            <a:r>
+              <a:rPr lang="fr-FR" dirty="0" err="1"/>
+              <a:t>nvidia</a:t>
+            </a:r>
+            <a:r>
+              <a:rPr lang="fr-FR" dirty="0"/>
+              <a:t> dans le docker-compose.yml:189) permettant d'accélérer massivement les prédictions </a:t>
+            </a:r>
+            <a:r>
+              <a:rPr lang="fr-FR" dirty="0" err="1"/>
+              <a:t>XGBoost</a:t>
+            </a:r>
+            <a:r>
+              <a:rPr lang="fr-FR" dirty="0"/>
+              <a:t> lors des pics de charge.</a:t>
+            </a:r>
+          </a:p>
+          <a:p>
+            <a:r>
+              <a:rPr lang="fr-FR" dirty="0"/>
+              <a:t>  ──────</a:t>
+            </a:r>
+          </a:p>
+          <a:p>
+            <a:r>
+              <a:rPr lang="fr-FR" dirty="0"/>
+              <a:t>  ### 3. Élimination complète des goulets d'étranglement</a:t>
+            </a:r>
+          </a:p>
+          <a:p>
+            <a:endParaRPr lang="fr-FR" dirty="0"/>
+          </a:p>
+          <a:p>
+            <a:r>
+              <a:rPr lang="fr-FR" dirty="0"/>
+              <a:t>  • Découplage Asynchrone : L'orchestrateur (</a:t>
+            </a:r>
+            <a:r>
+              <a:rPr lang="fr-FR" dirty="0" err="1"/>
+              <a:t>Airflow</a:t>
+            </a:r>
+            <a:r>
+              <a:rPr lang="fr-FR" dirty="0"/>
+              <a:t>) ne fait que coordonner. Il délègue le calcul lourd à Ray Head/Worker via </a:t>
+            </a:r>
+            <a:r>
+              <a:rPr lang="fr-FR" dirty="0" err="1"/>
+              <a:t>FastAPI</a:t>
+            </a:r>
+            <a:r>
+              <a:rPr lang="fr-FR" dirty="0"/>
+              <a:t> (/</a:t>
+            </a:r>
+            <a:r>
+              <a:rPr lang="fr-FR" dirty="0" err="1"/>
+              <a:t>predict_batch</a:t>
+            </a:r>
+            <a:r>
+              <a:rPr lang="fr-FR" dirty="0"/>
+              <a:t>), libérant ses propres ressources</a:t>
+            </a:r>
+          </a:p>
+          <a:p>
+            <a:r>
+              <a:rPr lang="fr-FR" dirty="0"/>
+              <a:t>  immédiatement.</a:t>
+            </a:r>
+          </a:p>
+          <a:p>
+            <a:r>
+              <a:rPr lang="fr-FR" dirty="0"/>
+              <a:t>  • Monopole de traitement (Max Active Runs = 1) : Le DAG est configuré avec </a:t>
+            </a:r>
+            <a:r>
+              <a:rPr lang="fr-FR" dirty="0" err="1"/>
+              <a:t>max_active_runs</a:t>
+            </a:r>
+            <a:r>
+              <a:rPr lang="fr-FR" dirty="0"/>
+              <a:t>=1 (dag_pipeline.py:235). Cela empêche plusieurs instances du pipeline de s'exécuter en</a:t>
+            </a:r>
+          </a:p>
+          <a:p>
+            <a:r>
+              <a:rPr lang="fr-FR" dirty="0"/>
+              <a:t>  parallèle et de créer des conflits d'accès (deadlocks) sur la base de données PostgreSQL ou sur le système de fichiers.</a:t>
+            </a:r>
+          </a:p>
+          <a:p>
+            <a:r>
+              <a:rPr lang="fr-FR" dirty="0"/>
+              <a:t>  • Utilisation de Redis en cache rapide (Online Store) : </a:t>
             </a:r>
             <a:r>
               <a:rPr lang="fr-FR" dirty="0" err="1"/>
@@ -3606,141 +3778,13 @@
             </a:r>
             <a:r>
               <a:rPr lang="fr-FR" dirty="0"/>
-              <a:t> garantit qu'il n'y a aucun effet de bord lié à l'environnement</a:t>
-            </a:r>
-          </a:p>
-          <a:p>
-            <a:r>
-              <a:rPr lang="fr-FR" dirty="0"/>
-              <a:t>  │ d'exécution ('</a:t>
-            </a:r>
-            <a:r>
-              <a:rPr lang="fr-FR" dirty="0" err="1"/>
-              <a:t>it</a:t>
-            </a:r>
-            <a:r>
-              <a:rPr lang="fr-FR" dirty="0"/>
-              <a:t> </a:t>
-            </a:r>
-            <a:r>
-              <a:rPr lang="fr-FR" dirty="0" err="1"/>
-              <a:t>works</a:t>
-            </a:r>
-            <a:r>
-              <a:rPr lang="fr-FR" dirty="0"/>
-              <a:t> on </a:t>
-            </a:r>
-            <a:r>
-              <a:rPr lang="fr-FR" dirty="0" err="1"/>
-              <a:t>my</a:t>
-            </a:r>
-            <a:r>
-              <a:rPr lang="fr-FR" dirty="0"/>
-              <a:t> machine'). Passer du développement à la production se résume à déployer les mêmes conteneurs sur des serveurs cloud."</a:t>
-            </a:r>
-          </a:p>
-          <a:p>
-            <a:endParaRPr lang="fr-FR" dirty="0"/>
-          </a:p>
-          <a:p>
-            <a:r>
-              <a:rPr lang="fr-FR" dirty="0"/>
-              <a:t>  • La transition vers le CT (</a:t>
-            </a:r>
-            <a:r>
-              <a:rPr lang="fr-FR" dirty="0" err="1"/>
-              <a:t>Continuous</a:t>
-            </a:r>
-            <a:r>
-              <a:rPr lang="fr-FR" dirty="0"/>
-              <a:t> Training) :</a:t>
-            </a:r>
-          </a:p>
-          <a:p>
-            <a:r>
-              <a:rPr lang="fr-FR" dirty="0"/>
-              <a:t>  │ "En </a:t>
-            </a:r>
-            <a:r>
-              <a:rPr lang="fr-FR" dirty="0" err="1"/>
-              <a:t>MLOps</a:t>
-            </a:r>
-            <a:r>
-              <a:rPr lang="fr-FR" dirty="0"/>
-              <a:t>, la CD ne s'arrête pas au déploiement du code, elle s'étend au déploiement du modèle. C'est le rôle de notre pipeline d'entraînement continu (CT) : dès que le monitoring</a:t>
-            </a:r>
-          </a:p>
-          <a:p>
-            <a:r>
-              <a:rPr lang="fr-FR" dirty="0"/>
-              <a:t>  │ (</a:t>
-            </a:r>
-            <a:r>
-              <a:rPr lang="fr-FR" dirty="0" err="1"/>
-              <a:t>Evidently</a:t>
-            </a:r>
-            <a:r>
-              <a:rPr lang="fr-FR" dirty="0"/>
-              <a:t>) détecte une baisse de performance ou un drift, un nouveau modèle est automatiquement entraîné, packagé par </a:t>
-            </a:r>
-            <a:r>
-              <a:rPr lang="fr-FR" dirty="0" err="1"/>
-              <a:t>MLflow</a:t>
-            </a:r>
-            <a:r>
-              <a:rPr lang="fr-FR" dirty="0"/>
-              <a:t>, et mis à disposition de l'API de prédiction sans</a:t>
-            </a:r>
-          </a:p>
-          <a:p>
-            <a:r>
-              <a:rPr lang="fr-FR" dirty="0"/>
-              <a:t>  │ interruption de service.« </a:t>
-            </a:r>
-          </a:p>
-          <a:p>
-            <a:endParaRPr lang="fr-FR" dirty="0"/>
-          </a:p>
-          <a:p>
-            <a:endParaRPr lang="fr-FR" dirty="0"/>
-          </a:p>
-          <a:p>
-            <a:endParaRPr lang="fr-FR" dirty="0"/>
-          </a:p>
-          <a:p>
-            <a:r>
-              <a:rPr lang="fr-FR" dirty="0"/>
-              <a:t>• Le fichier .</a:t>
-            </a:r>
-            <a:r>
-              <a:rPr lang="fr-FR" dirty="0" err="1"/>
-              <a:t>ruff.toml</a:t>
-            </a:r>
-            <a:r>
-              <a:rPr lang="fr-FR" dirty="0"/>
-              <a:t> configure les règles d'analyse statique du code.</a:t>
-            </a:r>
-          </a:p>
-          <a:p>
-            <a:r>
-              <a:rPr lang="fr-FR" dirty="0"/>
-              <a:t>  • Les fichiers </a:t>
-            </a:r>
-            <a:r>
-              <a:rPr lang="fr-FR" dirty="0" err="1"/>
-              <a:t>Dockerfile</a:t>
-            </a:r>
-            <a:r>
-              <a:rPr lang="fr-FR" dirty="0"/>
-              <a:t> dans le dossier docker et le docker-</a:t>
-            </a:r>
-            <a:r>
-              <a:rPr lang="fr-FR" dirty="0" err="1"/>
-              <a:t>compose.yml</a:t>
-            </a:r>
-            <a:r>
-              <a:rPr lang="fr-FR" dirty="0"/>
-              <a:t> orchestrent le déploiement multi-services.*</a:t>
+              <a:t> et l'API ne requêtent pas constamment PostgreSQL pour obtenir les règles de suspicion (SHAP). Elles lisent</a:t>
+            </a:r>
+          </a:p>
+          <a:p>
+            <a:r>
+              <a:rPr lang="fr-FR" dirty="0"/>
+              <a:t>  directement dans Redis (temps de réponse en microsecondes), évitant d'engorger la base de données relationnelle.</a:t>
             </a:r>
             <a:endParaRPr dirty="0"/>
           </a:p>
@@ -3751,7 +3795,7 @@
           <p:cNvPr id="4" name="Slide Number Placeholder 3">
             <a:extLst>
               <a:ext uri="{FF2B5EF4-FFF2-40B4-BE49-F238E27FC236}">
-                <a16:creationId xmlns:a16="http://schemas.microsoft.com/office/drawing/2014/main" id="{B8E8616A-1C3F-216E-714D-D3A183FC9F81}"/>
+                <a16:creationId xmlns:a16="http://schemas.microsoft.com/office/drawing/2014/main" id="{C3FB8016-F3D0-C2E9-664F-ACAF1D20A16A}"/>
               </a:ext>
             </a:extLst>
           </p:cNvPr>
@@ -3767,7 +3811,7 @@
     </p:spTree>
     <p:extLst>
       <p:ext uri="{BB962C8B-B14F-4D97-AF65-F5344CB8AC3E}">
-        <p14:creationId xmlns:p14="http://schemas.microsoft.com/office/powerpoint/2010/main" val="3138310562"/>
+        <p14:creationId xmlns:p14="http://schemas.microsoft.com/office/powerpoint/2010/main" val="1194679795"/>
       </p:ext>
     </p:extLst>
   </p:cSld>
@@ -3903,6 +3947,473 @@
 </file>
 
 <file path=ppt/notesSlides/notesSlide20.xml><?xml version="1.0" encoding="utf-8"?>
+<p:notes xmlns:a="http://schemas.openxmlformats.org/drawingml/2006/main" xmlns:r="http://schemas.openxmlformats.org/officeDocument/2006/relationships" xmlns:p="http://schemas.openxmlformats.org/presentationml/2006/main">
+  <p:cSld>
+    <p:spTree>
+      <p:nvGrpSpPr>
+        <p:cNvPr id="1" name="">
+          <a:extLst>
+            <a:ext uri="{FF2B5EF4-FFF2-40B4-BE49-F238E27FC236}">
+              <a16:creationId xmlns:a16="http://schemas.microsoft.com/office/drawing/2014/main" id="{C4874203-273A-E073-E960-A9FC0B486E64}"/>
+            </a:ext>
+          </a:extLst>
+        </p:cNvPr>
+        <p:cNvGrpSpPr/>
+        <p:nvPr/>
+      </p:nvGrpSpPr>
+      <p:grpSpPr>
+        <a:xfrm>
+          <a:off x="0" y="0"/>
+          <a:ext cx="0" cy="0"/>
+          <a:chOff x="0" y="0"/>
+          <a:chExt cx="0" cy="0"/>
+        </a:xfrm>
+      </p:grpSpPr>
+      <p:sp>
+        <p:nvSpPr>
+          <p:cNvPr id="2" name="Slide Image Placeholder 1">
+            <a:extLst>
+              <a:ext uri="{FF2B5EF4-FFF2-40B4-BE49-F238E27FC236}">
+                <a16:creationId xmlns:a16="http://schemas.microsoft.com/office/drawing/2014/main" id="{0E86EA60-FF27-4F6E-4DEA-A7A8913CD857}"/>
+              </a:ext>
+            </a:extLst>
+          </p:cNvPr>
+          <p:cNvSpPr>
+            <a:spLocks noGrp="1" noRot="1" noChangeAspect="1"/>
+          </p:cNvSpPr>
+          <p:nvPr>
+            <p:ph type="sldImg" idx="2"/>
+          </p:nvPr>
+        </p:nvSpPr>
+        <p:spPr/>
+      </p:sp>
+      <p:sp>
+        <p:nvSpPr>
+          <p:cNvPr id="3" name="Notes Placeholder 2">
+            <a:extLst>
+              <a:ext uri="{FF2B5EF4-FFF2-40B4-BE49-F238E27FC236}">
+                <a16:creationId xmlns:a16="http://schemas.microsoft.com/office/drawing/2014/main" id="{C58A4D2F-3122-A73A-7AA6-837D27C2911A}"/>
+              </a:ext>
+            </a:extLst>
+          </p:cNvPr>
+          <p:cNvSpPr>
+            <a:spLocks noGrp="1"/>
+          </p:cNvSpPr>
+          <p:nvPr>
+            <p:ph type="body" sz="quarter" idx="3"/>
+          </p:nvPr>
+        </p:nvSpPr>
+        <p:spPr/>
+        <p:txBody>
+          <a:bodyPr/>
+          <a:lstStyle/>
+          <a:p>
+            <a:pPr marL="0" marR="0" lvl="0" indent="0" algn="l" defTabSz="914400" rtl="0" eaLnBrk="1" fontAlgn="auto" latinLnBrk="0" hangingPunct="1">
+              <a:lnSpc>
+                <a:spcPct val="100000"/>
+              </a:lnSpc>
+              <a:spcBef>
+                <a:spcPts val="0"/>
+              </a:spcBef>
+              <a:spcAft>
+                <a:spcPts val="0"/>
+              </a:spcAft>
+              <a:buClrTx/>
+              <a:buSzTx/>
+              <a:buFontTx/>
+              <a:buNone/>
+              <a:tabLst/>
+              <a:defRPr/>
+            </a:pPr>
+            <a:r>
+              <a:rPr lang="fr-FR" sz="1200" b="0" kern="1200" dirty="0">
+                <a:solidFill>
+                  <a:schemeClr val="tx1"/>
+                </a:solidFill>
+                <a:effectLst/>
+                <a:latin typeface="+mn-lt"/>
+                <a:ea typeface="+mn-ea"/>
+                <a:cs typeface="+mn-cs"/>
+              </a:rPr>
+              <a:t>Le cycle de développement suit les principes modernes du DevOps et du </a:t>
+            </a:r>
+            <a:r>
+              <a:rPr lang="fr-FR" sz="1200" b="0" kern="1200" dirty="0" err="1">
+                <a:solidFill>
+                  <a:schemeClr val="tx1"/>
+                </a:solidFill>
+                <a:effectLst/>
+                <a:latin typeface="+mn-lt"/>
+                <a:ea typeface="+mn-ea"/>
+                <a:cs typeface="+mn-cs"/>
+              </a:rPr>
+              <a:t>MLOps</a:t>
+            </a:r>
+            <a:r>
+              <a:rPr lang="fr-FR" sz="1200" b="0" kern="1200" dirty="0">
+                <a:solidFill>
+                  <a:schemeClr val="tx1"/>
+                </a:solidFill>
+                <a:effectLst/>
+                <a:latin typeface="+mn-lt"/>
+                <a:ea typeface="+mn-ea"/>
+                <a:cs typeface="+mn-cs"/>
+              </a:rPr>
+              <a:t>. </a:t>
+            </a:r>
+          </a:p>
+          <a:p>
+            <a:pPr marL="0" marR="0" lvl="0" indent="0" algn="l" defTabSz="914400" rtl="0" eaLnBrk="1" fontAlgn="auto" latinLnBrk="0" hangingPunct="1">
+              <a:lnSpc>
+                <a:spcPct val="100000"/>
+              </a:lnSpc>
+              <a:spcBef>
+                <a:spcPts val="0"/>
+              </a:spcBef>
+              <a:spcAft>
+                <a:spcPts val="0"/>
+              </a:spcAft>
+              <a:buClrTx/>
+              <a:buSzTx/>
+              <a:buFontTx/>
+              <a:buNone/>
+              <a:tabLst/>
+              <a:defRPr/>
+            </a:pPr>
+            <a:r>
+              <a:rPr lang="fr-FR" sz="1200" b="0" kern="1200" dirty="0">
+                <a:solidFill>
+                  <a:schemeClr val="tx1"/>
+                </a:solidFill>
+                <a:effectLst/>
+                <a:latin typeface="+mn-lt"/>
+                <a:ea typeface="+mn-ea"/>
+                <a:cs typeface="+mn-cs"/>
+              </a:rPr>
+              <a:t>La CI valide la syntaxe avec Ruff et exécute les tests unitaires avec </a:t>
+            </a:r>
+            <a:r>
+              <a:rPr lang="fr-FR" sz="1200" b="0" kern="1200" dirty="0" err="1">
+                <a:solidFill>
+                  <a:schemeClr val="tx1"/>
+                </a:solidFill>
+                <a:effectLst/>
+                <a:latin typeface="+mn-lt"/>
+                <a:ea typeface="+mn-ea"/>
+                <a:cs typeface="+mn-cs"/>
+              </a:rPr>
+              <a:t>Pytest</a:t>
+            </a:r>
+            <a:r>
+              <a:rPr lang="fr-FR" sz="1200" b="0" kern="1200" dirty="0">
+                <a:solidFill>
+                  <a:schemeClr val="tx1"/>
+                </a:solidFill>
+                <a:effectLst/>
+                <a:latin typeface="+mn-lt"/>
+                <a:ea typeface="+mn-ea"/>
+                <a:cs typeface="+mn-cs"/>
+              </a:rPr>
+              <a:t> à chaque mise à jour.</a:t>
+            </a:r>
+          </a:p>
+          <a:p>
+            <a:pPr marL="0" marR="0" lvl="0" indent="0" algn="l" defTabSz="914400" rtl="0" eaLnBrk="1" fontAlgn="auto" latinLnBrk="0" hangingPunct="1">
+              <a:lnSpc>
+                <a:spcPct val="100000"/>
+              </a:lnSpc>
+              <a:spcBef>
+                <a:spcPts val="0"/>
+              </a:spcBef>
+              <a:spcAft>
+                <a:spcPts val="0"/>
+              </a:spcAft>
+              <a:buClrTx/>
+              <a:buSzTx/>
+              <a:buFontTx/>
+              <a:buNone/>
+              <a:tabLst/>
+              <a:defRPr/>
+            </a:pPr>
+            <a:r>
+              <a:rPr lang="fr-FR" sz="1200" b="0" kern="1200" dirty="0">
+                <a:solidFill>
+                  <a:schemeClr val="tx1"/>
+                </a:solidFill>
+                <a:effectLst/>
+                <a:latin typeface="+mn-lt"/>
+                <a:ea typeface="+mn-ea"/>
+                <a:cs typeface="+mn-cs"/>
+              </a:rPr>
+              <a:t> La CD assure la portabilité via Docker. Enfin, nous introduisons le CT — le </a:t>
+            </a:r>
+            <a:r>
+              <a:rPr lang="fr-FR" sz="1200" b="0" kern="1200" dirty="0" err="1">
+                <a:solidFill>
+                  <a:schemeClr val="tx1"/>
+                </a:solidFill>
+                <a:effectLst/>
+                <a:latin typeface="+mn-lt"/>
+                <a:ea typeface="+mn-ea"/>
+                <a:cs typeface="+mn-cs"/>
+              </a:rPr>
+              <a:t>Continuous</a:t>
+            </a:r>
+            <a:r>
+              <a:rPr lang="fr-FR" sz="1200" b="0" kern="1200" dirty="0">
+                <a:solidFill>
+                  <a:schemeClr val="tx1"/>
+                </a:solidFill>
+                <a:effectLst/>
+                <a:latin typeface="+mn-lt"/>
+                <a:ea typeface="+mn-ea"/>
+                <a:cs typeface="+mn-cs"/>
+              </a:rPr>
+              <a:t> Training : le système monitore en permanence les données et s'auto-corrige en déclenchant un réentraînement s'il détecte une dérive du modèle.</a:t>
+            </a:r>
+          </a:p>
+          <a:p>
+            <a:r>
+              <a:rPr lang="fr-FR" dirty="0"/>
+              <a:t> • Sur la CI (Qualité et Robustesse) :</a:t>
+            </a:r>
+          </a:p>
+          <a:p>
+            <a:r>
+              <a:rPr lang="fr-FR" dirty="0"/>
+              <a:t>  │ "Pour la partie Intégration Continue, nous avons mis en place des tests automatisés avec </a:t>
+            </a:r>
+            <a:r>
+              <a:rPr lang="fr-FR" dirty="0" err="1"/>
+              <a:t>pytest</a:t>
+            </a:r>
+            <a:r>
+              <a:rPr lang="fr-FR" dirty="0"/>
+              <a:t> et un contrôle de style strict avec </a:t>
+            </a:r>
+            <a:r>
+              <a:rPr lang="fr-FR" dirty="0" err="1"/>
+              <a:t>ruff</a:t>
+            </a:r>
+            <a:r>
+              <a:rPr lang="fr-FR" dirty="0"/>
+              <a:t>. Cela garantit que chaque modification de</a:t>
+            </a:r>
+          </a:p>
+          <a:p>
+            <a:r>
+              <a:rPr lang="fr-FR" dirty="0"/>
+              <a:t>  │ code (par exemple un nouveau calcul de </a:t>
+            </a:r>
+            <a:r>
+              <a:rPr lang="fr-FR" dirty="0" err="1"/>
+              <a:t>feature</a:t>
+            </a:r>
+            <a:r>
+              <a:rPr lang="fr-FR" dirty="0"/>
+              <a:t> pour détecter la fraude) ne casse pas le comportement existant du pipeline et respecte les standards de qualité de production."</a:t>
+            </a:r>
+          </a:p>
+          <a:p>
+            <a:endParaRPr lang="fr-FR" dirty="0"/>
+          </a:p>
+          <a:p>
+            <a:r>
+              <a:rPr lang="fr-FR" dirty="0"/>
+              <a:t>  • Sur la CD (Déploiement Reproductible) :</a:t>
+            </a:r>
+          </a:p>
+          <a:p>
+            <a:r>
+              <a:rPr lang="fr-FR" dirty="0"/>
+              <a:t>  │ "Le déploiement s'appuie entièrement sur Docker. L'utilisation d'images Docker dédiées pour Ray, </a:t>
+            </a:r>
+            <a:r>
+              <a:rPr lang="fr-FR" dirty="0" err="1"/>
+              <a:t>Airflow</a:t>
+            </a:r>
+            <a:r>
+              <a:rPr lang="fr-FR" dirty="0"/>
+              <a:t> et </a:t>
+            </a:r>
+            <a:r>
+              <a:rPr lang="fr-FR" dirty="0" err="1"/>
+              <a:t>Streamlit</a:t>
+            </a:r>
+            <a:r>
+              <a:rPr lang="fr-FR" dirty="0"/>
+              <a:t> garantit qu'il n'y a aucun effet de bord lié à l'environnement</a:t>
+            </a:r>
+          </a:p>
+          <a:p>
+            <a:r>
+              <a:rPr lang="fr-FR" dirty="0"/>
+              <a:t>  │ d'exécution ('</a:t>
+            </a:r>
+            <a:r>
+              <a:rPr lang="fr-FR" dirty="0" err="1"/>
+              <a:t>it</a:t>
+            </a:r>
+            <a:r>
+              <a:rPr lang="fr-FR" dirty="0"/>
+              <a:t> </a:t>
+            </a:r>
+            <a:r>
+              <a:rPr lang="fr-FR" dirty="0" err="1"/>
+              <a:t>works</a:t>
+            </a:r>
+            <a:r>
+              <a:rPr lang="fr-FR" dirty="0"/>
+              <a:t> on </a:t>
+            </a:r>
+            <a:r>
+              <a:rPr lang="fr-FR" dirty="0" err="1"/>
+              <a:t>my</a:t>
+            </a:r>
+            <a:r>
+              <a:rPr lang="fr-FR" dirty="0"/>
+              <a:t> machine'). Passer du développement à la production se résume à déployer les mêmes conteneurs sur des serveurs cloud."</a:t>
+            </a:r>
+          </a:p>
+          <a:p>
+            <a:endParaRPr lang="fr-FR" dirty="0"/>
+          </a:p>
+          <a:p>
+            <a:r>
+              <a:rPr lang="fr-FR" dirty="0"/>
+              <a:t>  • La transition vers le CT (</a:t>
+            </a:r>
+            <a:r>
+              <a:rPr lang="fr-FR" dirty="0" err="1"/>
+              <a:t>Continuous</a:t>
+            </a:r>
+            <a:r>
+              <a:rPr lang="fr-FR" dirty="0"/>
+              <a:t> Training) :</a:t>
+            </a:r>
+          </a:p>
+          <a:p>
+            <a:r>
+              <a:rPr lang="fr-FR" dirty="0"/>
+              <a:t>  │ "En </a:t>
+            </a:r>
+            <a:r>
+              <a:rPr lang="fr-FR" dirty="0" err="1"/>
+              <a:t>MLOps</a:t>
+            </a:r>
+            <a:r>
+              <a:rPr lang="fr-FR" dirty="0"/>
+              <a:t>, la CD ne s'arrête pas au déploiement du code, elle s'étend au déploiement du modèle. C'est le rôle de notre pipeline d'entraînement continu (CT) : dès que le monitoring</a:t>
+            </a:r>
+          </a:p>
+          <a:p>
+            <a:r>
+              <a:rPr lang="fr-FR" dirty="0"/>
+              <a:t>  │ (</a:t>
+            </a:r>
+            <a:r>
+              <a:rPr lang="fr-FR" dirty="0" err="1"/>
+              <a:t>Evidently</a:t>
+            </a:r>
+            <a:r>
+              <a:rPr lang="fr-FR" dirty="0"/>
+              <a:t>) détecte une baisse de performance ou un drift, un nouveau modèle est automatiquement entraîné, packagé par </a:t>
+            </a:r>
+            <a:r>
+              <a:rPr lang="fr-FR" dirty="0" err="1"/>
+              <a:t>MLflow</a:t>
+            </a:r>
+            <a:r>
+              <a:rPr lang="fr-FR" dirty="0"/>
+              <a:t>, et mis à disposition de l'API de prédiction sans</a:t>
+            </a:r>
+          </a:p>
+          <a:p>
+            <a:r>
+              <a:rPr lang="fr-FR" dirty="0"/>
+              <a:t>  │ interruption de service.« </a:t>
+            </a:r>
+          </a:p>
+          <a:p>
+            <a:endParaRPr lang="fr-FR" dirty="0"/>
+          </a:p>
+          <a:p>
+            <a:endParaRPr lang="fr-FR" dirty="0"/>
+          </a:p>
+          <a:p>
+            <a:endParaRPr lang="fr-FR" dirty="0"/>
+          </a:p>
+          <a:p>
+            <a:r>
+              <a:rPr lang="fr-FR" dirty="0"/>
+              <a:t>• Le fichier .</a:t>
+            </a:r>
+            <a:r>
+              <a:rPr lang="fr-FR" dirty="0" err="1"/>
+              <a:t>ruff.toml</a:t>
+            </a:r>
+            <a:r>
+              <a:rPr lang="fr-FR" dirty="0"/>
+              <a:t> configure les règles d'analyse statique du code.</a:t>
+            </a:r>
+          </a:p>
+          <a:p>
+            <a:r>
+              <a:rPr lang="fr-FR" dirty="0"/>
+              <a:t>  • Les fichiers </a:t>
+            </a:r>
+            <a:r>
+              <a:rPr lang="fr-FR" dirty="0" err="1"/>
+              <a:t>Dockerfile</a:t>
+            </a:r>
+            <a:r>
+              <a:rPr lang="fr-FR" dirty="0"/>
+              <a:t> dans le dossier docker et le docker-</a:t>
+            </a:r>
+            <a:r>
+              <a:rPr lang="fr-FR" dirty="0" err="1"/>
+              <a:t>compose.yml</a:t>
+            </a:r>
+            <a:r>
+              <a:rPr lang="fr-FR" dirty="0"/>
+              <a:t> orchestrent le déploiement multi-services.*</a:t>
+            </a:r>
+            <a:endParaRPr dirty="0"/>
+          </a:p>
+        </p:txBody>
+      </p:sp>
+      <p:sp>
+        <p:nvSpPr>
+          <p:cNvPr id="4" name="Slide Number Placeholder 3">
+            <a:extLst>
+              <a:ext uri="{FF2B5EF4-FFF2-40B4-BE49-F238E27FC236}">
+                <a16:creationId xmlns:a16="http://schemas.microsoft.com/office/drawing/2014/main" id="{B8E8616A-1C3F-216E-714D-D3A183FC9F81}"/>
+              </a:ext>
+            </a:extLst>
+          </p:cNvPr>
+          <p:cNvSpPr>
+            <a:spLocks noGrp="1"/>
+          </p:cNvSpPr>
+          <p:nvPr>
+            <p:ph type="sldNum" sz="quarter" idx="5"/>
+          </p:nvPr>
+        </p:nvSpPr>
+        <p:spPr/>
+      </p:sp>
+    </p:spTree>
+    <p:extLst>
+      <p:ext uri="{BB962C8B-B14F-4D97-AF65-F5344CB8AC3E}">
+        <p14:creationId xmlns:p14="http://schemas.microsoft.com/office/powerpoint/2010/main" val="3138310562"/>
+      </p:ext>
+    </p:extLst>
+  </p:cSld>
+  <p:clrMapOvr>
+    <a:masterClrMapping/>
+  </p:clrMapOvr>
+</p:notes>
+</file>
+
+<file path=ppt/notesSlides/notesSlide21.xml><?xml version="1.0" encoding="utf-8"?>
 <p:notes xmlns:a="http://schemas.openxmlformats.org/drawingml/2006/main" xmlns:r="http://schemas.openxmlformats.org/officeDocument/2006/relationships" xmlns:p="http://schemas.openxmlformats.org/presentationml/2006/main">
   <p:cSld>
     <p:spTree>
@@ -10760,8 +11271,8 @@
         </p:nvSpPr>
         <p:spPr>
           <a:xfrm>
-            <a:off x="615963" y="1612759"/>
-            <a:ext cx="5120640" cy="2778369"/>
+            <a:off x="539763" y="1612759"/>
+            <a:ext cx="5120640" cy="3692666"/>
           </a:xfrm>
           <a:prstGeom prst="roundRect">
             <a:avLst/>
@@ -10832,7 +11343,7 @@
             </a:r>
             <a:r>
               <a:rPr lang="fr-FR" dirty="0"/>
-              <a:t>) : Calculé en direct pour chaque transaction.</a:t>
+              <a:t>) : Calculé en direct pour chaque transaction. </a:t>
             </a:r>
           </a:p>
           <a:p>
@@ -10849,7 +11360,15 @@
             </a:pPr>
             <a:r>
               <a:rPr lang="fr-FR" dirty="0"/>
-              <a:t>• Explications enregistrées en base </a:t>
+              <a:t>• </a:t>
+            </a:r>
+            <a:r>
+              <a:rPr lang="fr-FR" dirty="0" err="1"/>
+              <a:t>Shap</a:t>
+            </a:r>
+            <a:r>
+              <a:rPr lang="fr-FR" dirty="0"/>
+              <a:t> values enregistrées en base </a:t>
             </a:r>
             <a:r>
               <a:rPr lang="fr-FR" dirty="0" err="1"/>
@@ -10857,8 +11376,17 @@
             </a:r>
             <a:r>
               <a:rPr lang="fr-FR" dirty="0"/>
-              <a:t> </a:t>
-            </a:r>
+              <a:t>  pour les transactions frauduleuses </a:t>
+            </a:r>
+            <a:r>
+              <a:rPr lang="fr-FR" b="1" dirty="0"/>
+              <a:t>uniquement </a:t>
+            </a:r>
+            <a:r>
+              <a:rPr lang="fr-FR" dirty="0"/>
+              <a:t>(limite coûts de stockage)</a:t>
+            </a:r>
+            <a:endParaRPr lang="fr-FR" b="1" dirty="0"/>
           </a:p>
           <a:p>
             <a:pPr>
@@ -10936,7 +11464,7 @@
         <p:spPr>
           <a:xfrm>
             <a:off x="6157964" y="1612759"/>
-            <a:ext cx="5237201" cy="2949191"/>
+            <a:ext cx="5237201" cy="3692666"/>
           </a:xfrm>
           <a:prstGeom prst="roundRect">
             <a:avLst/>
@@ -11079,7 +11607,7 @@
           <a:p>
             <a:pPr>
               <a:spcAft>
-                <a:spcPts val="0"/>
+                <a:spcPts val="800"/>
               </a:spcAft>
               <a:defRPr sz="1200" b="0">
                 <a:solidFill>
@@ -11088,7 +11616,40 @@
                 <a:latin typeface="Segoe UI"/>
               </a:defRPr>
             </a:pPr>
-            <a:endParaRPr dirty="0"/>
+            <a:r>
+              <a:rPr lang="fr-FR" dirty="0"/>
+              <a:t>• </a:t>
+            </a:r>
+            <a:r>
+              <a:rPr lang="fr-FR" dirty="0" err="1"/>
+              <a:t>Webhook</a:t>
+            </a:r>
+            <a:r>
+              <a:rPr lang="fr-FR" dirty="0"/>
+              <a:t> marchand dans </a:t>
+            </a:r>
+            <a:r>
+              <a:rPr lang="fr-FR" dirty="0" err="1"/>
+              <a:t>fastAPI</a:t>
+            </a:r>
+            <a:r>
+              <a:rPr lang="fr-FR" dirty="0"/>
+              <a:t> http://localhost:8001/docs#/default/mock_merchant_webhook_mock_merchant_webhook_post</a:t>
+            </a:r>
+          </a:p>
+          <a:p>
+            <a:pPr>
+              <a:spcAft>
+                <a:spcPts val="800"/>
+              </a:spcAft>
+              <a:defRPr sz="1200" b="0">
+                <a:solidFill>
+                  <a:srgbClr val="475569"/>
+                </a:solidFill>
+                <a:latin typeface="Segoe UI"/>
+              </a:defRPr>
+            </a:pPr>
+            <a:endParaRPr lang="fr-FR" dirty="0"/>
           </a:p>
         </p:txBody>
       </p:sp>
@@ -12816,7 +13377,7 @@
         <p:cNvPr id="1" name="">
           <a:extLst>
             <a:ext uri="{FF2B5EF4-FFF2-40B4-BE49-F238E27FC236}">
-              <a16:creationId xmlns:a16="http://schemas.microsoft.com/office/drawing/2014/main" id="{8F8EEDEA-E5C6-DA9A-0A55-1C964F13CC33}"/>
+              <a16:creationId xmlns:a16="http://schemas.microsoft.com/office/drawing/2014/main" id="{FB880094-6EE4-1E4D-99A8-B248BF7A2C0A}"/>
             </a:ext>
           </a:extLst>
         </p:cNvPr>
@@ -12836,7 +13397,7 @@
           <p:cNvPr id="4" name="Rounded Rectangle 3">
             <a:extLst>
               <a:ext uri="{FF2B5EF4-FFF2-40B4-BE49-F238E27FC236}">
-                <a16:creationId xmlns:a16="http://schemas.microsoft.com/office/drawing/2014/main" id="{3DB3E866-1851-9433-6AAC-272EF202B6C7}"/>
+                <a16:creationId xmlns:a16="http://schemas.microsoft.com/office/drawing/2014/main" id="{3E7BC986-AE5C-0174-0967-8A4CAA9214B8}"/>
               </a:ext>
             </a:extLst>
           </p:cNvPr>
@@ -12891,7 +13452,7 @@
             </a:pPr>
             <a:r>
               <a:rPr lang="fr-FR" dirty="0"/>
-              <a:t>Fiabilité</a:t>
+              <a:t>PCI-DSS</a:t>
             </a:r>
             <a:endParaRPr dirty="0"/>
           </a:p>
@@ -12927,11 +13488,11 @@
             </a:r>
             <a:r>
               <a:rPr lang="fr-FR" b="1" dirty="0"/>
-              <a:t>Ingestion continue sans perte de données</a:t>
-            </a:r>
-            <a:r>
-              <a:rPr lang="fr-FR" dirty="0"/>
-              <a:t>, même en cas de panne de base de données.</a:t>
+              <a:t>Obligation :  </a:t>
+            </a:r>
+            <a:r>
+              <a:rPr lang="fr-FR" dirty="0"/>
+              <a:t>Protection des données des titulaires de cartes (CHD) et interdiction de stocker ou faire circuler le numéro de carte en clair dans les logs ou les notifications</a:t>
             </a:r>
           </a:p>
           <a:p>
@@ -12985,7 +13546,7 @@
             </a:r>
             <a:r>
               <a:rPr lang="fr-FR" b="1" dirty="0"/>
-              <a:t>Tolérance aux pannes &amp; préparation à la haute disponibilité:</a:t>
+              <a:t>Implémentation :</a:t>
             </a:r>
             <a:endParaRPr lang="fr-FR" dirty="0"/>
           </a:p>
@@ -13003,7 +13564,23 @@
             </a:pPr>
             <a:r>
               <a:rPr lang="fr-FR" dirty="0"/>
-              <a:t>   • L'arrêt d'un composant (ex: Ray ou PostgreSQL) n'entraîne pas la perte des données entrantes, qui restent stockées en toute sécurité dans la queue d’ingestion</a:t>
+              <a:t>    -Hachage systématique : Les numéros de cartes (</a:t>
+            </a:r>
+            <a:r>
+              <a:rPr lang="fr-FR" dirty="0" err="1"/>
+              <a:t>cc_num</a:t>
+            </a:r>
+            <a:r>
+              <a:rPr lang="fr-FR" dirty="0"/>
+              <a:t>) sont chiffrés à la volée via un hachage cryptographique SHA-256 fort lors de l'affichage dans l'application et de l'envoi des </a:t>
+            </a:r>
+            <a:r>
+              <a:rPr lang="fr-FR" dirty="0" err="1"/>
+              <a:t>webhooks</a:t>
+            </a:r>
+            <a:r>
+              <a:rPr lang="fr-FR" dirty="0"/>
+              <a:t> aux marchands.</a:t>
             </a:r>
           </a:p>
           <a:p>
@@ -13019,48 +13596,20 @@
               </a:defRPr>
             </a:pPr>
             <a:r>
-              <a:rPr lang="fr-FR" dirty="0"/>
-              <a:t>   •  </a:t>
-            </a:r>
-            <a:r>
-              <a:rPr lang="fr-FR" b="1" dirty="0"/>
-              <a:t>Architecture prête pour le Cloud </a:t>
-            </a:r>
-            <a:r>
-              <a:rPr lang="fr-FR" dirty="0"/>
-              <a:t>: Grâce à Docker-compose et au cluster Ray, chaque brique (</a:t>
+              <a:rPr lang="fr-FR"/>
+              <a:t>      - </a:t>
+            </a:r>
+            <a:r>
+              <a:rPr lang="fr-FR" dirty="0"/>
+              <a:t>Zéro fuite de données : Aucun numéro de carte en clair n'est écrit dans le cache Redis de suivi, dans les logs système, ou dans les </a:t>
             </a:r>
             <a:r>
               <a:rPr lang="fr-FR" dirty="0" err="1"/>
-              <a:t>Postgres</a:t>
-            </a:r>
-            <a:r>
-              <a:rPr lang="fr-FR" dirty="0"/>
-              <a:t>, Ray </a:t>
-            </a:r>
-            <a:r>
-              <a:rPr lang="fr-FR" dirty="0" err="1"/>
-              <a:t>Workers</a:t>
-            </a:r>
-            <a:r>
-              <a:rPr lang="fr-FR" dirty="0"/>
-              <a:t>, </a:t>
-            </a:r>
-            <a:r>
-              <a:rPr lang="fr-FR" dirty="0" err="1"/>
-              <a:t>Airflow</a:t>
-            </a:r>
-            <a:r>
-              <a:rPr lang="fr-FR" dirty="0"/>
-              <a:t>) peut être déployée sur des serveurs distincts et répliquée (ex: avec </a:t>
-            </a:r>
-            <a:r>
-              <a:rPr lang="fr-FR" dirty="0" err="1"/>
-              <a:t>Kubernetes</a:t>
-            </a:r>
-            <a:r>
-              <a:rPr lang="fr-FR" dirty="0"/>
-              <a:t> ou AWS) pour éliminer physiquement tout Single Point Of Failure</a:t>
+              <a:t>payloads</a:t>
+            </a:r>
+            <a:r>
+              <a:rPr lang="fr-FR" dirty="0"/>
+              <a:t> API.   </a:t>
             </a:r>
           </a:p>
         </p:txBody>
@@ -13070,7 +13619,7 @@
           <p:cNvPr id="5" name="Rounded Rectangle 4">
             <a:extLst>
               <a:ext uri="{FF2B5EF4-FFF2-40B4-BE49-F238E27FC236}">
-                <a16:creationId xmlns:a16="http://schemas.microsoft.com/office/drawing/2014/main" id="{6041327F-E866-6418-D045-DD86EE730ACE}"/>
+                <a16:creationId xmlns:a16="http://schemas.microsoft.com/office/drawing/2014/main" id="{E07F2128-7BB5-46F6-1E90-3D22035D96BC}"/>
               </a:ext>
             </a:extLst>
           </p:cNvPr>
@@ -13295,7 +13844,7 @@
           <p:cNvPr id="6" name="Rounded Rectangle 5">
             <a:extLst>
               <a:ext uri="{FF2B5EF4-FFF2-40B4-BE49-F238E27FC236}">
-                <a16:creationId xmlns:a16="http://schemas.microsoft.com/office/drawing/2014/main" id="{5E9881E7-9817-93B1-6CE7-031556A22B0F}"/>
+                <a16:creationId xmlns:a16="http://schemas.microsoft.com/office/drawing/2014/main" id="{870B52E1-C9B3-4CB1-6625-10FF0B9D93A3}"/>
               </a:ext>
             </a:extLst>
           </p:cNvPr>
@@ -13470,7 +14019,7 @@
           <p:cNvPr id="8" name="TextBox 2">
             <a:extLst>
               <a:ext uri="{FF2B5EF4-FFF2-40B4-BE49-F238E27FC236}">
-                <a16:creationId xmlns:a16="http://schemas.microsoft.com/office/drawing/2014/main" id="{720C1452-CE83-3272-E34F-B1FDC92255D5}"/>
+                <a16:creationId xmlns:a16="http://schemas.microsoft.com/office/drawing/2014/main" id="{D3A07C34-8869-DB6E-F11A-007A4F3557E3}"/>
               </a:ext>
             </a:extLst>
           </p:cNvPr>
@@ -13503,11 +14052,15 @@
             </a:pPr>
             <a:r>
               <a:rPr lang="fr-FR" dirty="0"/>
-              <a:t>Conception sécurisée et résilience </a:t>
+              <a:t>Conformité Réglementaire &amp; Sécurité (RGPD, AI </a:t>
             </a:r>
             <a:r>
               <a:rPr lang="fr-FR" dirty="0" err="1"/>
-              <a:t>MLOps</a:t>
+              <a:t>Act</a:t>
+            </a:r>
+            <a:r>
+              <a:rPr lang="fr-FR" dirty="0"/>
+              <a:t>, PCI-DSS)</a:t>
             </a:r>
             <a:endParaRPr dirty="0"/>
           </a:p>
@@ -13518,7 +14071,7 @@
           <p:cNvPr id="12" name="Rectangle 11">
             <a:extLst>
               <a:ext uri="{FF2B5EF4-FFF2-40B4-BE49-F238E27FC236}">
-                <a16:creationId xmlns:a16="http://schemas.microsoft.com/office/drawing/2014/main" id="{73885B3B-1FF0-7570-BCA0-127D472291AF}"/>
+                <a16:creationId xmlns:a16="http://schemas.microsoft.com/office/drawing/2014/main" id="{6E5627F3-C2BF-2CB3-1644-30B4499331B6}"/>
               </a:ext>
             </a:extLst>
           </p:cNvPr>
@@ -13568,7 +14121,7 @@
           <p:cNvPr id="3" name="TextBox 1">
             <a:extLst>
               <a:ext uri="{FF2B5EF4-FFF2-40B4-BE49-F238E27FC236}">
-                <a16:creationId xmlns:a16="http://schemas.microsoft.com/office/drawing/2014/main" id="{0574E3FF-E7CA-0FB6-AEC6-FB41D2F3FF69}"/>
+                <a16:creationId xmlns:a16="http://schemas.microsoft.com/office/drawing/2014/main" id="{9393DC65-7B01-7AC9-2241-2CE29CFF3448}"/>
               </a:ext>
             </a:extLst>
           </p:cNvPr>
@@ -13610,6 +14163,826 @@
     </p:spTree>
     <p:extLst>
       <p:ext uri="{BB962C8B-B14F-4D97-AF65-F5344CB8AC3E}">
+        <p14:creationId xmlns:p14="http://schemas.microsoft.com/office/powerpoint/2010/main" val="325816632"/>
+      </p:ext>
+    </p:extLst>
+  </p:cSld>
+  <p:clrMapOvr>
+    <a:masterClrMapping/>
+  </p:clrMapOvr>
+</p:sld>
+</file>
+
+<file path=ppt/slides/slide19.xml><?xml version="1.0" encoding="utf-8"?>
+<p:sld xmlns:a="http://schemas.openxmlformats.org/drawingml/2006/main" xmlns:r="http://schemas.openxmlformats.org/officeDocument/2006/relationships" xmlns:p="http://schemas.openxmlformats.org/presentationml/2006/main">
+  <p:cSld>
+    <p:bg>
+      <p:bgPr>
+        <a:solidFill>
+          <a:srgbClr val="F8FAFC"/>
+        </a:solidFill>
+        <a:effectLst/>
+      </p:bgPr>
+    </p:bg>
+    <p:spTree>
+      <p:nvGrpSpPr>
+        <p:cNvPr id="1" name="">
+          <a:extLst>
+            <a:ext uri="{FF2B5EF4-FFF2-40B4-BE49-F238E27FC236}">
+              <a16:creationId xmlns:a16="http://schemas.microsoft.com/office/drawing/2014/main" id="{8F8EEDEA-E5C6-DA9A-0A55-1C964F13CC33}"/>
+            </a:ext>
+          </a:extLst>
+        </p:cNvPr>
+        <p:cNvGrpSpPr/>
+        <p:nvPr/>
+      </p:nvGrpSpPr>
+      <p:grpSpPr>
+        <a:xfrm>
+          <a:off x="0" y="0"/>
+          <a:ext cx="0" cy="0"/>
+          <a:chOff x="0" y="0"/>
+          <a:chExt cx="0" cy="0"/>
+        </a:xfrm>
+      </p:grpSpPr>
+      <p:sp>
+        <p:nvSpPr>
+          <p:cNvPr id="4" name="Rounded Rectangle 3">
+            <a:extLst>
+              <a:ext uri="{FF2B5EF4-FFF2-40B4-BE49-F238E27FC236}">
+                <a16:creationId xmlns:a16="http://schemas.microsoft.com/office/drawing/2014/main" id="{3DB3E866-1851-9433-6AAC-272EF202B6C7}"/>
+              </a:ext>
+            </a:extLst>
+          </p:cNvPr>
+          <p:cNvSpPr/>
+          <p:nvPr/>
+        </p:nvSpPr>
+        <p:spPr>
+          <a:xfrm>
+            <a:off x="731520" y="994470"/>
+            <a:ext cx="3291840" cy="5375850"/>
+          </a:xfrm>
+          <a:prstGeom prst="roundRect">
+            <a:avLst/>
+          </a:prstGeom>
+          <a:solidFill>
+            <a:srgbClr val="FFFFFF"/>
+          </a:solidFill>
+          <a:ln w="12700">
+            <a:solidFill>
+              <a:srgbClr val="E2E8F0"/>
+            </a:solidFill>
+          </a:ln>
+        </p:spPr>
+        <p:style>
+          <a:lnRef idx="1">
+            <a:schemeClr val="accent1"/>
+          </a:lnRef>
+          <a:fillRef idx="3">
+            <a:schemeClr val="accent1"/>
+          </a:fillRef>
+          <a:effectRef idx="2">
+            <a:schemeClr val="accent1"/>
+          </a:effectRef>
+          <a:fontRef idx="minor">
+            <a:schemeClr val="lt1"/>
+          </a:fontRef>
+        </p:style>
+        <p:txBody>
+          <a:bodyPr wrap="square" lIns="228600" tIns="228600" rIns="228600" bIns="228600" rtlCol="0" anchor="ctr"/>
+          <a:lstStyle/>
+          <a:p>
+            <a:pPr>
+              <a:spcAft>
+                <a:spcPts val="200"/>
+              </a:spcAft>
+              <a:defRPr sz="2800" b="1">
+                <a:solidFill>
+                  <a:srgbClr val="635BFF"/>
+                </a:solidFill>
+                <a:latin typeface="Segoe UI"/>
+              </a:defRPr>
+            </a:pPr>
+            <a:r>
+              <a:rPr lang="fr-FR" dirty="0"/>
+              <a:t>Fiabilité</a:t>
+            </a:r>
+            <a:endParaRPr dirty="0"/>
+          </a:p>
+          <a:p>
+            <a:pPr>
+              <a:spcAft>
+                <a:spcPts val="800"/>
+              </a:spcAft>
+              <a:defRPr sz="1200" b="0">
+                <a:solidFill>
+                  <a:srgbClr val="475569"/>
+                </a:solidFill>
+                <a:latin typeface="Segoe UI"/>
+              </a:defRPr>
+            </a:pPr>
+            <a:endParaRPr lang="fr-FR" dirty="0"/>
+          </a:p>
+          <a:p>
+            <a:pPr>
+              <a:spcAft>
+                <a:spcPts val="800"/>
+              </a:spcAft>
+              <a:defRPr sz="1200" b="0">
+                <a:solidFill>
+                  <a:srgbClr val="475569"/>
+                </a:solidFill>
+                <a:latin typeface="Segoe UI"/>
+              </a:defRPr>
+            </a:pPr>
+            <a:r>
+              <a:rPr lang="fr-FR" dirty="0"/>
+              <a:t>• </a:t>
+            </a:r>
+            <a:r>
+              <a:rPr lang="fr-FR" b="1" dirty="0"/>
+              <a:t>Ingestion continue sans perte de données</a:t>
+            </a:r>
+            <a:r>
+              <a:rPr lang="fr-FR" dirty="0"/>
+              <a:t>, même en cas de panne de base de données.</a:t>
+            </a:r>
+          </a:p>
+          <a:p>
+            <a:pPr>
+              <a:spcAft>
+                <a:spcPts val="800"/>
+              </a:spcAft>
+              <a:defRPr sz="1200" b="0">
+                <a:solidFill>
+                  <a:srgbClr val="475569"/>
+                </a:solidFill>
+                <a:latin typeface="Segoe UI"/>
+              </a:defRPr>
+            </a:pPr>
+            <a:r>
+              <a:rPr dirty="0"/>
+              <a:t>• Absorption </a:t>
+            </a:r>
+            <a:r>
+              <a:rPr dirty="0" err="1"/>
+              <a:t>fluide</a:t>
+            </a:r>
+            <a:r>
+              <a:rPr dirty="0"/>
+              <a:t> des charges </a:t>
+            </a:r>
+            <a:r>
+              <a:rPr dirty="0" err="1"/>
+              <a:t>transactionnelles</a:t>
+            </a:r>
+            <a:r>
+              <a:rPr dirty="0"/>
+              <a:t> de pointe.</a:t>
+            </a:r>
+          </a:p>
+          <a:p>
+            <a:pPr>
+              <a:spcAft>
+                <a:spcPts val="0"/>
+              </a:spcAft>
+              <a:defRPr sz="1200" b="0">
+                <a:solidFill>
+                  <a:srgbClr val="475569"/>
+                </a:solidFill>
+                <a:latin typeface="Segoe UI"/>
+              </a:defRPr>
+            </a:pPr>
+            <a:r>
+              <a:rPr lang="fr-FR" dirty="0"/>
+              <a:t>• </a:t>
+            </a:r>
+            <a:r>
+              <a:rPr lang="fr-FR" b="1" dirty="0"/>
+              <a:t>Tolérance aux pannes &amp; préparation à la haute disponibilité:</a:t>
+            </a:r>
+            <a:endParaRPr lang="fr-FR" dirty="0"/>
+          </a:p>
+          <a:p>
+            <a:pPr>
+              <a:spcAft>
+                <a:spcPts val="0"/>
+              </a:spcAft>
+              <a:defRPr sz="1200" b="0">
+                <a:solidFill>
+                  <a:srgbClr val="475569"/>
+                </a:solidFill>
+                <a:latin typeface="Segoe UI"/>
+              </a:defRPr>
+            </a:pPr>
+            <a:r>
+              <a:rPr lang="fr-FR" dirty="0"/>
+              <a:t>   • L'arrêt d'un composant (ex: Ray ou PostgreSQL) n'entraîne pas la perte des données entrantes, qui restent stockées en toute sécurité dans la queue d’ingestion</a:t>
+            </a:r>
+          </a:p>
+          <a:p>
+            <a:pPr>
+              <a:spcAft>
+                <a:spcPts val="0"/>
+              </a:spcAft>
+              <a:defRPr sz="1200" b="0">
+                <a:solidFill>
+                  <a:srgbClr val="475569"/>
+                </a:solidFill>
+                <a:latin typeface="Segoe UI"/>
+              </a:defRPr>
+            </a:pPr>
+            <a:r>
+              <a:rPr lang="fr-FR" dirty="0"/>
+              <a:t>   •  </a:t>
+            </a:r>
+            <a:r>
+              <a:rPr lang="fr-FR" b="1" dirty="0"/>
+              <a:t>Architecture prête pour le Cloud </a:t>
+            </a:r>
+            <a:r>
+              <a:rPr lang="fr-FR" dirty="0"/>
+              <a:t>: Grâce à Docker-compose et au cluster Ray, chaque brique (</a:t>
+            </a:r>
+            <a:r>
+              <a:rPr lang="fr-FR" dirty="0" err="1"/>
+              <a:t>Postgres</a:t>
+            </a:r>
+            <a:r>
+              <a:rPr lang="fr-FR" dirty="0"/>
+              <a:t>, Ray </a:t>
+            </a:r>
+            <a:r>
+              <a:rPr lang="fr-FR" dirty="0" err="1"/>
+              <a:t>Workers</a:t>
+            </a:r>
+            <a:r>
+              <a:rPr lang="fr-FR" dirty="0"/>
+              <a:t>, </a:t>
+            </a:r>
+            <a:r>
+              <a:rPr lang="fr-FR" dirty="0" err="1"/>
+              <a:t>Airflow</a:t>
+            </a:r>
+            <a:r>
+              <a:rPr lang="fr-FR" dirty="0"/>
+              <a:t>) peut être déployée sur des serveurs distincts et répliquée (ex: avec </a:t>
+            </a:r>
+            <a:r>
+              <a:rPr lang="fr-FR" dirty="0" err="1"/>
+              <a:t>Kubernetes</a:t>
+            </a:r>
+            <a:r>
+              <a:rPr lang="fr-FR" dirty="0"/>
+              <a:t> ou AWS) pour éliminer physiquement tout Single Point Of Failure</a:t>
+            </a:r>
+          </a:p>
+        </p:txBody>
+      </p:sp>
+      <p:sp>
+        <p:nvSpPr>
+          <p:cNvPr id="5" name="Rounded Rectangle 4">
+            <a:extLst>
+              <a:ext uri="{FF2B5EF4-FFF2-40B4-BE49-F238E27FC236}">
+                <a16:creationId xmlns:a16="http://schemas.microsoft.com/office/drawing/2014/main" id="{6041327F-E866-6418-D045-DD86EE730ACE}"/>
+              </a:ext>
+            </a:extLst>
+          </p:cNvPr>
+          <p:cNvSpPr/>
+          <p:nvPr/>
+        </p:nvSpPr>
+        <p:spPr>
+          <a:xfrm>
+            <a:off x="4522470" y="994470"/>
+            <a:ext cx="3291840" cy="5551170"/>
+          </a:xfrm>
+          <a:prstGeom prst="roundRect">
+            <a:avLst/>
+          </a:prstGeom>
+          <a:solidFill>
+            <a:srgbClr val="FFFFFF"/>
+          </a:solidFill>
+          <a:ln w="19050">
+            <a:solidFill>
+              <a:srgbClr val="10B981"/>
+            </a:solidFill>
+          </a:ln>
+        </p:spPr>
+        <p:style>
+          <a:lnRef idx="1">
+            <a:schemeClr val="accent1"/>
+          </a:lnRef>
+          <a:fillRef idx="3">
+            <a:schemeClr val="accent1"/>
+          </a:fillRef>
+          <a:effectRef idx="2">
+            <a:schemeClr val="accent1"/>
+          </a:effectRef>
+          <a:fontRef idx="minor">
+            <a:schemeClr val="lt1"/>
+          </a:fontRef>
+        </p:style>
+        <p:txBody>
+          <a:bodyPr wrap="square" lIns="228600" tIns="228600" rIns="228600" bIns="228600" rtlCol="0" anchor="ctr"/>
+          <a:lstStyle/>
+          <a:p>
+            <a:pPr>
+              <a:spcAft>
+                <a:spcPts val="200"/>
+              </a:spcAft>
+              <a:defRPr sz="2800" b="1">
+                <a:solidFill>
+                  <a:srgbClr val="10B981"/>
+                </a:solidFill>
+                <a:latin typeface="Segoe UI"/>
+              </a:defRPr>
+            </a:pPr>
+            <a:r>
+              <a:rPr lang="fr-FR" dirty="0"/>
+              <a:t>Gouvernance </a:t>
+            </a:r>
+            <a:r>
+              <a:rPr lang="fr-FR" dirty="0" err="1"/>
+              <a:t>MLOps</a:t>
+            </a:r>
+            <a:endParaRPr dirty="0"/>
+          </a:p>
+          <a:p>
+            <a:pPr>
+              <a:spcAft>
+                <a:spcPts val="800"/>
+              </a:spcAft>
+              <a:defRPr sz="1200" b="0">
+                <a:solidFill>
+                  <a:srgbClr val="475569"/>
+                </a:solidFill>
+                <a:latin typeface="Segoe UI"/>
+              </a:defRPr>
+            </a:pPr>
+            <a:endParaRPr lang="fr-FR" dirty="0"/>
+          </a:p>
+          <a:p>
+            <a:pPr>
+              <a:spcAft>
+                <a:spcPts val="800"/>
+              </a:spcAft>
+              <a:defRPr sz="1200" b="0">
+                <a:solidFill>
+                  <a:srgbClr val="475569"/>
+                </a:solidFill>
+                <a:latin typeface="Segoe UI"/>
+              </a:defRPr>
+            </a:pPr>
+            <a:r>
+              <a:rPr lang="fr-FR" dirty="0"/>
+              <a:t>•</a:t>
+            </a:r>
+            <a:r>
+              <a:rPr lang="fr-FR" b="1" dirty="0"/>
+              <a:t> </a:t>
+            </a:r>
+            <a:r>
+              <a:rPr lang="fr-FR" b="1" dirty="0" err="1"/>
+              <a:t>Auditabilité</a:t>
+            </a:r>
+            <a:r>
+              <a:rPr lang="fr-FR" b="1" dirty="0"/>
+              <a:t> &amp; Reproductibilité </a:t>
+            </a:r>
+            <a:r>
+              <a:rPr lang="fr-FR" dirty="0"/>
+              <a:t>: Suivi centralisé (</a:t>
+            </a:r>
+            <a:r>
+              <a:rPr lang="fr-FR" dirty="0" err="1"/>
+              <a:t>MLflow</a:t>
+            </a:r>
+            <a:r>
+              <a:rPr lang="fr-FR" dirty="0"/>
+              <a:t>) de chaque modèle (code, paramètres, métriques et données associées).</a:t>
+            </a:r>
+          </a:p>
+          <a:p>
+            <a:pPr>
+              <a:spcAft>
+                <a:spcPts val="800"/>
+              </a:spcAft>
+              <a:defRPr sz="1200" b="0">
+                <a:solidFill>
+                  <a:srgbClr val="475569"/>
+                </a:solidFill>
+                <a:latin typeface="Segoe UI"/>
+              </a:defRPr>
+            </a:pPr>
+            <a:r>
+              <a:rPr lang="fr-FR" dirty="0"/>
+              <a:t> • </a:t>
+            </a:r>
+            <a:r>
+              <a:rPr lang="fr-FR" b="1" dirty="0"/>
+              <a:t>Gestion des versions </a:t>
+            </a:r>
+            <a:r>
+              <a:rPr lang="fr-FR" dirty="0"/>
+              <a:t>: Registre de modèles unique garantissant que l'API de production interroge toujours la version validée et certifiée.</a:t>
+            </a:r>
+          </a:p>
+          <a:p>
+            <a:pPr>
+              <a:spcAft>
+                <a:spcPts val="800"/>
+              </a:spcAft>
+              <a:defRPr sz="1200" b="0">
+                <a:solidFill>
+                  <a:srgbClr val="475569"/>
+                </a:solidFill>
+                <a:latin typeface="Segoe UI"/>
+              </a:defRPr>
+            </a:pPr>
+            <a:r>
+              <a:rPr lang="fr-FR" dirty="0"/>
+              <a:t> • </a:t>
+            </a:r>
+            <a:r>
+              <a:rPr lang="fr-FR" b="1" dirty="0"/>
+              <a:t>Contrôle de la dérive (Drift) : </a:t>
+            </a:r>
+            <a:r>
+              <a:rPr lang="fr-FR" dirty="0"/>
+              <a:t>Audit quotidien automatisé (</a:t>
+            </a:r>
+            <a:r>
+              <a:rPr lang="fr-FR" dirty="0" err="1"/>
+              <a:t>Evidently</a:t>
+            </a:r>
+            <a:r>
+              <a:rPr lang="fr-FR" dirty="0"/>
+              <a:t>) pour détecter tout décalage entre les données réelles et le modèle.</a:t>
+            </a:r>
+          </a:p>
+          <a:p>
+            <a:pPr>
+              <a:spcAft>
+                <a:spcPts val="800"/>
+              </a:spcAft>
+              <a:defRPr sz="1200" b="0">
+                <a:solidFill>
+                  <a:srgbClr val="475569"/>
+                </a:solidFill>
+                <a:latin typeface="Segoe UI"/>
+              </a:defRPr>
+            </a:pPr>
+            <a:r>
+              <a:rPr lang="fr-FR" dirty="0"/>
+              <a:t> • </a:t>
+            </a:r>
+            <a:r>
+              <a:rPr lang="fr-FR" b="1" dirty="0"/>
+              <a:t>Boucle d'amélioration continue </a:t>
+            </a:r>
+            <a:r>
+              <a:rPr lang="fr-FR" dirty="0"/>
+              <a:t>: Réentraînement automatisé (</a:t>
+            </a:r>
+            <a:r>
+              <a:rPr lang="fr-FR" dirty="0" err="1"/>
+              <a:t>Optuna</a:t>
+            </a:r>
+            <a:r>
+              <a:rPr lang="fr-FR" dirty="0"/>
+              <a:t> + </a:t>
+            </a:r>
+            <a:r>
+              <a:rPr lang="fr-FR" dirty="0" err="1"/>
+              <a:t>XGBoost</a:t>
+            </a:r>
+            <a:r>
+              <a:rPr lang="fr-FR" dirty="0"/>
+              <a:t>) déclenché sur alerte pour maintenir la performance dans le temps.</a:t>
+            </a:r>
+            <a:endParaRPr dirty="0"/>
+          </a:p>
+        </p:txBody>
+      </p:sp>
+      <p:sp>
+        <p:nvSpPr>
+          <p:cNvPr id="6" name="Rounded Rectangle 5">
+            <a:extLst>
+              <a:ext uri="{FF2B5EF4-FFF2-40B4-BE49-F238E27FC236}">
+                <a16:creationId xmlns:a16="http://schemas.microsoft.com/office/drawing/2014/main" id="{5E9881E7-9817-93B1-6CE7-031556A22B0F}"/>
+              </a:ext>
+            </a:extLst>
+          </p:cNvPr>
+          <p:cNvSpPr/>
+          <p:nvPr/>
+        </p:nvSpPr>
+        <p:spPr>
+          <a:xfrm>
+            <a:off x="8168642" y="986790"/>
+            <a:ext cx="3291840" cy="5551170"/>
+          </a:xfrm>
+          <a:prstGeom prst="roundRect">
+            <a:avLst/>
+          </a:prstGeom>
+          <a:solidFill>
+            <a:srgbClr val="FFFFFF"/>
+          </a:solidFill>
+          <a:ln w="12700">
+            <a:solidFill>
+              <a:srgbClr val="E2E8F0"/>
+            </a:solidFill>
+          </a:ln>
+        </p:spPr>
+        <p:style>
+          <a:lnRef idx="1">
+            <a:schemeClr val="accent1"/>
+          </a:lnRef>
+          <a:fillRef idx="3">
+            <a:schemeClr val="accent1"/>
+          </a:fillRef>
+          <a:effectRef idx="2">
+            <a:schemeClr val="accent1"/>
+          </a:effectRef>
+          <a:fontRef idx="minor">
+            <a:schemeClr val="lt1"/>
+          </a:fontRef>
+        </p:style>
+        <p:txBody>
+          <a:bodyPr wrap="square" lIns="228600" tIns="228600" rIns="228600" bIns="228600" rtlCol="0" anchor="ctr"/>
+          <a:lstStyle/>
+          <a:p>
+            <a:pPr>
+              <a:spcAft>
+                <a:spcPts val="200"/>
+              </a:spcAft>
+              <a:defRPr sz="2800" b="1">
+                <a:solidFill>
+                  <a:srgbClr val="0F172A"/>
+                </a:solidFill>
+                <a:latin typeface="Segoe UI"/>
+              </a:defRPr>
+            </a:pPr>
+            <a:r>
+              <a:rPr lang="fr-FR" dirty="0"/>
+              <a:t>Sécurité</a:t>
+            </a:r>
+            <a:endParaRPr dirty="0"/>
+          </a:p>
+          <a:p>
+            <a:pPr>
+              <a:spcAft>
+                <a:spcPts val="800"/>
+              </a:spcAft>
+              <a:defRPr sz="1200" b="0">
+                <a:solidFill>
+                  <a:srgbClr val="475569"/>
+                </a:solidFill>
+                <a:latin typeface="Segoe UI"/>
+              </a:defRPr>
+            </a:pPr>
+            <a:endParaRPr lang="fr-FR" dirty="0"/>
+          </a:p>
+          <a:p>
+            <a:pPr>
+              <a:spcAft>
+                <a:spcPts val="800"/>
+              </a:spcAft>
+              <a:defRPr sz="1200" b="0">
+                <a:solidFill>
+                  <a:srgbClr val="475569"/>
+                </a:solidFill>
+                <a:latin typeface="Segoe UI"/>
+              </a:defRPr>
+            </a:pPr>
+            <a:r>
+              <a:rPr lang="fr-FR" dirty="0"/>
+              <a:t>• </a:t>
+            </a:r>
+            <a:r>
+              <a:rPr lang="fr-FR" b="1" dirty="0"/>
+              <a:t>Cryptage des flux </a:t>
+            </a:r>
+            <a:r>
+              <a:rPr lang="fr-FR" dirty="0"/>
+              <a:t>: Les échanges externes (accès utilisateurs et notifications marchandes) sont cryptés de bout en bout via le protocole HTTPS (géré par notre passerelle d'accès)</a:t>
+            </a:r>
+          </a:p>
+          <a:p>
+            <a:pPr>
+              <a:spcAft>
+                <a:spcPts val="800"/>
+              </a:spcAft>
+              <a:defRPr sz="1200" b="0">
+                <a:solidFill>
+                  <a:srgbClr val="475569"/>
+                </a:solidFill>
+                <a:latin typeface="Segoe UI"/>
+              </a:defRPr>
+            </a:pPr>
+            <a:r>
+              <a:rPr lang="fr-FR" b="1" dirty="0"/>
+              <a:t>• Contrôle d'accès</a:t>
+            </a:r>
+            <a:r>
+              <a:rPr lang="fr-FR" dirty="0"/>
+              <a:t> : Sécurisation </a:t>
+            </a:r>
+            <a:r>
+              <a:rPr lang="fr-FR" b="1" dirty="0"/>
+              <a:t>prévue</a:t>
+            </a:r>
+            <a:r>
+              <a:rPr lang="fr-FR" dirty="0"/>
+              <a:t> des </a:t>
+            </a:r>
+            <a:r>
+              <a:rPr lang="fr-FR" dirty="0" err="1"/>
+              <a:t>webhooks</a:t>
+            </a:r>
+            <a:r>
+              <a:rPr lang="fr-FR" dirty="0"/>
+              <a:t> marchands par signature cryptographique (HMAC) avec secret partagé pour garantir l'authenticité des alertes de fraude.</a:t>
+            </a:r>
+          </a:p>
+          <a:p>
+            <a:pPr>
+              <a:spcAft>
+                <a:spcPts val="800"/>
+              </a:spcAft>
+              <a:defRPr sz="1200" b="0">
+                <a:solidFill>
+                  <a:srgbClr val="475569"/>
+                </a:solidFill>
+                <a:latin typeface="Segoe UI"/>
+              </a:defRPr>
+            </a:pPr>
+            <a:r>
+              <a:rPr lang="fr-FR" dirty="0"/>
+              <a:t>•  </a:t>
+            </a:r>
+            <a:r>
+              <a:rPr lang="fr-FR" b="1" dirty="0"/>
+              <a:t>RGPD &amp; Confidentialité </a:t>
+            </a:r>
+            <a:r>
+              <a:rPr lang="fr-FR" dirty="0"/>
+              <a:t>: Limitation stricte des données transmises. Les </a:t>
+            </a:r>
+            <a:r>
+              <a:rPr lang="fr-FR" dirty="0" err="1"/>
+              <a:t>webhooks</a:t>
+            </a:r>
+            <a:r>
+              <a:rPr lang="fr-FR" dirty="0"/>
+              <a:t> de notification n'embarquent aucune donnée hautement sensible (comme le numéro de carte bancaire complet ou l'identité de l'acheteur), uniquement des jetons de transaction anonymisés et le statut de fraude.</a:t>
+            </a:r>
+          </a:p>
+        </p:txBody>
+      </p:sp>
+      <p:sp>
+        <p:nvSpPr>
+          <p:cNvPr id="8" name="TextBox 2">
+            <a:extLst>
+              <a:ext uri="{FF2B5EF4-FFF2-40B4-BE49-F238E27FC236}">
+                <a16:creationId xmlns:a16="http://schemas.microsoft.com/office/drawing/2014/main" id="{720C1452-CE83-3272-E34F-B1FDC92255D5}"/>
+              </a:ext>
+            </a:extLst>
+          </p:cNvPr>
+          <p:cNvSpPr txBox="1"/>
+          <p:nvPr/>
+        </p:nvSpPr>
+        <p:spPr>
+          <a:xfrm>
+            <a:off x="731520" y="499110"/>
+            <a:ext cx="10698480" cy="400110"/>
+          </a:xfrm>
+          <a:prstGeom prst="rect">
+            <a:avLst/>
+          </a:prstGeom>
+          <a:noFill/>
+        </p:spPr>
+        <p:txBody>
+          <a:bodyPr wrap="square" lIns="0" tIns="0" rIns="0" bIns="0">
+            <a:spAutoFit/>
+          </a:bodyPr>
+          <a:lstStyle/>
+          <a:p>
+            <a:pPr>
+              <a:defRPr sz="2600" b="1">
+                <a:solidFill>
+                  <a:srgbClr val="0F172A"/>
+                </a:solidFill>
+                <a:latin typeface="Segoe UI"/>
+              </a:defRPr>
+            </a:pPr>
+            <a:r>
+              <a:rPr lang="fr-FR" dirty="0"/>
+              <a:t>Conception sécurisée et résilience </a:t>
+            </a:r>
+            <a:r>
+              <a:rPr lang="fr-FR" dirty="0" err="1"/>
+              <a:t>MLOps</a:t>
+            </a:r>
+            <a:endParaRPr dirty="0"/>
+          </a:p>
+        </p:txBody>
+      </p:sp>
+      <p:sp>
+        <p:nvSpPr>
+          <p:cNvPr id="12" name="Rectangle 11">
+            <a:extLst>
+              <a:ext uri="{FF2B5EF4-FFF2-40B4-BE49-F238E27FC236}">
+                <a16:creationId xmlns:a16="http://schemas.microsoft.com/office/drawing/2014/main" id="{73885B3B-1FF0-7570-BCA0-127D472291AF}"/>
+              </a:ext>
+            </a:extLst>
+          </p:cNvPr>
+          <p:cNvSpPr/>
+          <p:nvPr/>
+        </p:nvSpPr>
+        <p:spPr>
+          <a:xfrm>
+            <a:off x="0" y="0"/>
+            <a:ext cx="228600" cy="6858000"/>
+          </a:xfrm>
+          <a:prstGeom prst="rect">
+            <a:avLst/>
+          </a:prstGeom>
+          <a:solidFill>
+            <a:srgbClr val="635BFF"/>
+          </a:solidFill>
+          <a:ln>
+            <a:noFill/>
+          </a:ln>
+        </p:spPr>
+        <p:style>
+          <a:lnRef idx="1">
+            <a:schemeClr val="accent1"/>
+          </a:lnRef>
+          <a:fillRef idx="3">
+            <a:schemeClr val="accent1"/>
+          </a:fillRef>
+          <a:effectRef idx="2">
+            <a:schemeClr val="accent1"/>
+          </a:effectRef>
+          <a:fontRef idx="minor">
+            <a:schemeClr val="lt1"/>
+          </a:fontRef>
+        </p:style>
+        <p:txBody>
+          <a:bodyPr rtlCol="0" anchor="ctr"/>
+          <a:lstStyle/>
+          <a:p>
+            <a:pPr algn="ctr"/>
+            <a:endParaRPr/>
+          </a:p>
+        </p:txBody>
+      </p:sp>
+      <p:sp>
+        <p:nvSpPr>
+          <p:cNvPr id="3" name="TextBox 1">
+            <a:extLst>
+              <a:ext uri="{FF2B5EF4-FFF2-40B4-BE49-F238E27FC236}">
+                <a16:creationId xmlns:a16="http://schemas.microsoft.com/office/drawing/2014/main" id="{0574E3FF-E7CA-0FB6-AEC6-FB41D2F3FF69}"/>
+              </a:ext>
+            </a:extLst>
+          </p:cNvPr>
+          <p:cNvSpPr txBox="1"/>
+          <p:nvPr/>
+        </p:nvSpPr>
+        <p:spPr>
+          <a:xfrm>
+            <a:off x="731520" y="320040"/>
+            <a:ext cx="10698480" cy="146194"/>
+          </a:xfrm>
+          <a:prstGeom prst="rect">
+            <a:avLst/>
+          </a:prstGeom>
+          <a:noFill/>
+        </p:spPr>
+        <p:txBody>
+          <a:bodyPr wrap="square" lIns="0" tIns="0" rIns="0" bIns="0">
+            <a:spAutoFit/>
+          </a:bodyPr>
+          <a:lstStyle/>
+          <a:p>
+            <a:pPr>
+              <a:defRPr sz="950" b="1">
+                <a:solidFill>
+                  <a:srgbClr val="635BFF"/>
+                </a:solidFill>
+                <a:latin typeface="Segoe UI"/>
+              </a:defRPr>
+            </a:pPr>
+            <a:r>
+              <a:rPr lang="fr-FR" dirty="0"/>
+              <a:t>2. Qualité logicielle, CICD &amp; robustesse </a:t>
+            </a:r>
+            <a:endParaRPr dirty="0"/>
+          </a:p>
+        </p:txBody>
+      </p:sp>
+    </p:spTree>
+    <p:extLst>
+      <p:ext uri="{BB962C8B-B14F-4D97-AF65-F5344CB8AC3E}">
         <p14:creationId xmlns:p14="http://schemas.microsoft.com/office/powerpoint/2010/main" val="1739148237"/>
       </p:ext>
     </p:extLst>
@@ -13620,7 +14993,185 @@
 </p:sld>
 </file>
 
-<file path=ppt/slides/slide19.xml><?xml version="1.0" encoding="utf-8"?>
+<file path=ppt/slides/slide2.xml><?xml version="1.0" encoding="utf-8"?>
+<p:sld xmlns:a="http://schemas.openxmlformats.org/drawingml/2006/main" xmlns:r="http://schemas.openxmlformats.org/officeDocument/2006/relationships" xmlns:p="http://schemas.openxmlformats.org/presentationml/2006/main">
+  <p:cSld>
+    <p:spTree>
+      <p:nvGrpSpPr>
+        <p:cNvPr id="1" name="">
+          <a:extLst>
+            <a:ext uri="{FF2B5EF4-FFF2-40B4-BE49-F238E27FC236}">
+              <a16:creationId xmlns:a16="http://schemas.microsoft.com/office/drawing/2014/main" id="{CB5BD9F7-59DB-AA9E-559E-450F06F4BF9B}"/>
+            </a:ext>
+          </a:extLst>
+        </p:cNvPr>
+        <p:cNvGrpSpPr/>
+        <p:nvPr/>
+      </p:nvGrpSpPr>
+      <p:grpSpPr>
+        <a:xfrm>
+          <a:off x="0" y="0"/>
+          <a:ext cx="0" cy="0"/>
+          <a:chOff x="0" y="0"/>
+          <a:chExt cx="0" cy="0"/>
+        </a:xfrm>
+      </p:grpSpPr>
+      <p:sp>
+        <p:nvSpPr>
+          <p:cNvPr id="2" name="Rectangle 1">
+            <a:extLst>
+              <a:ext uri="{FF2B5EF4-FFF2-40B4-BE49-F238E27FC236}">
+                <a16:creationId xmlns:a16="http://schemas.microsoft.com/office/drawing/2014/main" id="{AA25B514-1F1A-D325-826F-EDBEA14F2F91}"/>
+              </a:ext>
+            </a:extLst>
+          </p:cNvPr>
+          <p:cNvSpPr/>
+          <p:nvPr/>
+        </p:nvSpPr>
+        <p:spPr>
+          <a:xfrm>
+            <a:off x="0" y="0"/>
+            <a:ext cx="228600" cy="6858000"/>
+          </a:xfrm>
+          <a:prstGeom prst="rect">
+            <a:avLst/>
+          </a:prstGeom>
+          <a:solidFill>
+            <a:srgbClr val="635BFF"/>
+          </a:solidFill>
+          <a:ln>
+            <a:noFill/>
+          </a:ln>
+        </p:spPr>
+        <p:style>
+          <a:lnRef idx="1">
+            <a:schemeClr val="accent1"/>
+          </a:lnRef>
+          <a:fillRef idx="3">
+            <a:schemeClr val="accent1"/>
+          </a:fillRef>
+          <a:effectRef idx="2">
+            <a:schemeClr val="accent1"/>
+          </a:effectRef>
+          <a:fontRef idx="minor">
+            <a:schemeClr val="lt1"/>
+          </a:fontRef>
+        </p:style>
+        <p:txBody>
+          <a:bodyPr rtlCol="0" anchor="ctr"/>
+          <a:lstStyle/>
+          <a:p>
+            <a:pPr algn="ctr"/>
+            <a:endParaRPr/>
+          </a:p>
+        </p:txBody>
+      </p:sp>
+      <p:sp>
+        <p:nvSpPr>
+          <p:cNvPr id="5" name="TextBox 2">
+            <a:extLst>
+              <a:ext uri="{FF2B5EF4-FFF2-40B4-BE49-F238E27FC236}">
+                <a16:creationId xmlns:a16="http://schemas.microsoft.com/office/drawing/2014/main" id="{E38B619C-A4A1-49AA-7768-A8B80DE775C9}"/>
+              </a:ext>
+            </a:extLst>
+          </p:cNvPr>
+          <p:cNvSpPr txBox="1"/>
+          <p:nvPr/>
+        </p:nvSpPr>
+        <p:spPr>
+          <a:xfrm>
+            <a:off x="1081668" y="1534408"/>
+            <a:ext cx="10332720" cy="1497846"/>
+          </a:xfrm>
+          <a:prstGeom prst="rect">
+            <a:avLst/>
+          </a:prstGeom>
+          <a:noFill/>
+        </p:spPr>
+        <p:txBody>
+          <a:bodyPr wrap="square" lIns="0" tIns="0" rIns="0" bIns="0">
+            <a:spAutoFit/>
+          </a:bodyPr>
+          <a:lstStyle/>
+          <a:p>
+            <a:pPr>
+              <a:spcAft>
+                <a:spcPts val="800"/>
+              </a:spcAft>
+              <a:defRPr sz="3800" b="1">
+                <a:solidFill>
+                  <a:srgbClr val="0F172A"/>
+                </a:solidFill>
+                <a:latin typeface="Segoe UI"/>
+              </a:defRPr>
+            </a:pPr>
+            <a:r>
+              <a:rPr lang="fr-FR" sz="2800" dirty="0">
+                <a:solidFill>
+                  <a:srgbClr val="10B981"/>
+                </a:solidFill>
+              </a:rPr>
+              <a:t>1. Contexte métier &amp; cadrage</a:t>
+            </a:r>
+          </a:p>
+          <a:p>
+            <a:pPr>
+              <a:spcAft>
+                <a:spcPts val="800"/>
+              </a:spcAft>
+              <a:defRPr sz="3800" b="1">
+                <a:solidFill>
+                  <a:srgbClr val="0F172A"/>
+                </a:solidFill>
+                <a:latin typeface="Segoe UI"/>
+              </a:defRPr>
+            </a:pPr>
+            <a:r>
+              <a:rPr lang="fr-FR" sz="2800" dirty="0">
+                <a:solidFill>
+                  <a:srgbClr val="64748B"/>
+                </a:solidFill>
+              </a:rPr>
+              <a:t>2. Architecture</a:t>
+            </a:r>
+          </a:p>
+          <a:p>
+            <a:pPr>
+              <a:spcAft>
+                <a:spcPts val="800"/>
+              </a:spcAft>
+              <a:defRPr sz="3800" b="1">
+                <a:solidFill>
+                  <a:srgbClr val="0F172A"/>
+                </a:solidFill>
+                <a:latin typeface="Segoe UI"/>
+              </a:defRPr>
+            </a:pPr>
+            <a:r>
+              <a:rPr lang="fr-FR" sz="2800" dirty="0">
+                <a:solidFill>
+                  <a:srgbClr val="64748B"/>
+                </a:solidFill>
+              </a:rPr>
+              <a:t>3. Qualité logicielle, CICD &amp; robustesse </a:t>
+            </a:r>
+          </a:p>
+        </p:txBody>
+      </p:sp>
+    </p:spTree>
+    <p:extLst>
+      <p:ext uri="{BB962C8B-B14F-4D97-AF65-F5344CB8AC3E}">
+        <p14:creationId xmlns:p14="http://schemas.microsoft.com/office/powerpoint/2010/main" val="253780104"/>
+      </p:ext>
+    </p:extLst>
+  </p:cSld>
+  <p:clrMapOvr>
+    <a:masterClrMapping/>
+  </p:clrMapOvr>
+</p:sld>
+</file>
+
+<file path=ppt/slides/slide20.xml><?xml version="1.0" encoding="utf-8"?>
 <p:sld xmlns:a="http://schemas.openxmlformats.org/drawingml/2006/main" xmlns:r="http://schemas.openxmlformats.org/officeDocument/2006/relationships" xmlns:p="http://schemas.openxmlformats.org/presentationml/2006/main">
   <p:cSld>
     <p:bg>
@@ -14159,185 +15710,7 @@
 </p:sld>
 </file>
 
-<file path=ppt/slides/slide2.xml><?xml version="1.0" encoding="utf-8"?>
-<p:sld xmlns:a="http://schemas.openxmlformats.org/drawingml/2006/main" xmlns:r="http://schemas.openxmlformats.org/officeDocument/2006/relationships" xmlns:p="http://schemas.openxmlformats.org/presentationml/2006/main">
-  <p:cSld>
-    <p:spTree>
-      <p:nvGrpSpPr>
-        <p:cNvPr id="1" name="">
-          <a:extLst>
-            <a:ext uri="{FF2B5EF4-FFF2-40B4-BE49-F238E27FC236}">
-              <a16:creationId xmlns:a16="http://schemas.microsoft.com/office/drawing/2014/main" id="{CB5BD9F7-59DB-AA9E-559E-450F06F4BF9B}"/>
-            </a:ext>
-          </a:extLst>
-        </p:cNvPr>
-        <p:cNvGrpSpPr/>
-        <p:nvPr/>
-      </p:nvGrpSpPr>
-      <p:grpSpPr>
-        <a:xfrm>
-          <a:off x="0" y="0"/>
-          <a:ext cx="0" cy="0"/>
-          <a:chOff x="0" y="0"/>
-          <a:chExt cx="0" cy="0"/>
-        </a:xfrm>
-      </p:grpSpPr>
-      <p:sp>
-        <p:nvSpPr>
-          <p:cNvPr id="2" name="Rectangle 1">
-            <a:extLst>
-              <a:ext uri="{FF2B5EF4-FFF2-40B4-BE49-F238E27FC236}">
-                <a16:creationId xmlns:a16="http://schemas.microsoft.com/office/drawing/2014/main" id="{AA25B514-1F1A-D325-826F-EDBEA14F2F91}"/>
-              </a:ext>
-            </a:extLst>
-          </p:cNvPr>
-          <p:cNvSpPr/>
-          <p:nvPr/>
-        </p:nvSpPr>
-        <p:spPr>
-          <a:xfrm>
-            <a:off x="0" y="0"/>
-            <a:ext cx="228600" cy="6858000"/>
-          </a:xfrm>
-          <a:prstGeom prst="rect">
-            <a:avLst/>
-          </a:prstGeom>
-          <a:solidFill>
-            <a:srgbClr val="635BFF"/>
-          </a:solidFill>
-          <a:ln>
-            <a:noFill/>
-          </a:ln>
-        </p:spPr>
-        <p:style>
-          <a:lnRef idx="1">
-            <a:schemeClr val="accent1"/>
-          </a:lnRef>
-          <a:fillRef idx="3">
-            <a:schemeClr val="accent1"/>
-          </a:fillRef>
-          <a:effectRef idx="2">
-            <a:schemeClr val="accent1"/>
-          </a:effectRef>
-          <a:fontRef idx="minor">
-            <a:schemeClr val="lt1"/>
-          </a:fontRef>
-        </p:style>
-        <p:txBody>
-          <a:bodyPr rtlCol="0" anchor="ctr"/>
-          <a:lstStyle/>
-          <a:p>
-            <a:pPr algn="ctr"/>
-            <a:endParaRPr/>
-          </a:p>
-        </p:txBody>
-      </p:sp>
-      <p:sp>
-        <p:nvSpPr>
-          <p:cNvPr id="5" name="TextBox 2">
-            <a:extLst>
-              <a:ext uri="{FF2B5EF4-FFF2-40B4-BE49-F238E27FC236}">
-                <a16:creationId xmlns:a16="http://schemas.microsoft.com/office/drawing/2014/main" id="{E38B619C-A4A1-49AA-7768-A8B80DE775C9}"/>
-              </a:ext>
-            </a:extLst>
-          </p:cNvPr>
-          <p:cNvSpPr txBox="1"/>
-          <p:nvPr/>
-        </p:nvSpPr>
-        <p:spPr>
-          <a:xfrm>
-            <a:off x="1081668" y="1534408"/>
-            <a:ext cx="10332720" cy="1497846"/>
-          </a:xfrm>
-          <a:prstGeom prst="rect">
-            <a:avLst/>
-          </a:prstGeom>
-          <a:noFill/>
-        </p:spPr>
-        <p:txBody>
-          <a:bodyPr wrap="square" lIns="0" tIns="0" rIns="0" bIns="0">
-            <a:spAutoFit/>
-          </a:bodyPr>
-          <a:lstStyle/>
-          <a:p>
-            <a:pPr>
-              <a:spcAft>
-                <a:spcPts val="800"/>
-              </a:spcAft>
-              <a:defRPr sz="3800" b="1">
-                <a:solidFill>
-                  <a:srgbClr val="0F172A"/>
-                </a:solidFill>
-                <a:latin typeface="Segoe UI"/>
-              </a:defRPr>
-            </a:pPr>
-            <a:r>
-              <a:rPr lang="fr-FR" sz="2800" dirty="0">
-                <a:solidFill>
-                  <a:srgbClr val="10B981"/>
-                </a:solidFill>
-              </a:rPr>
-              <a:t>1. Contexte métier &amp; cadrage</a:t>
-            </a:r>
-          </a:p>
-          <a:p>
-            <a:pPr>
-              <a:spcAft>
-                <a:spcPts val="800"/>
-              </a:spcAft>
-              <a:defRPr sz="3800" b="1">
-                <a:solidFill>
-                  <a:srgbClr val="0F172A"/>
-                </a:solidFill>
-                <a:latin typeface="Segoe UI"/>
-              </a:defRPr>
-            </a:pPr>
-            <a:r>
-              <a:rPr lang="fr-FR" sz="2800" dirty="0">
-                <a:solidFill>
-                  <a:srgbClr val="64748B"/>
-                </a:solidFill>
-              </a:rPr>
-              <a:t>2. Architecture</a:t>
-            </a:r>
-          </a:p>
-          <a:p>
-            <a:pPr>
-              <a:spcAft>
-                <a:spcPts val="800"/>
-              </a:spcAft>
-              <a:defRPr sz="3800" b="1">
-                <a:solidFill>
-                  <a:srgbClr val="0F172A"/>
-                </a:solidFill>
-                <a:latin typeface="Segoe UI"/>
-              </a:defRPr>
-            </a:pPr>
-            <a:r>
-              <a:rPr lang="fr-FR" sz="2800" dirty="0">
-                <a:solidFill>
-                  <a:srgbClr val="64748B"/>
-                </a:solidFill>
-              </a:rPr>
-              <a:t>3. Qualité logicielle, CICD &amp; robustesse </a:t>
-            </a:r>
-          </a:p>
-        </p:txBody>
-      </p:sp>
-    </p:spTree>
-    <p:extLst>
-      <p:ext uri="{BB962C8B-B14F-4D97-AF65-F5344CB8AC3E}">
-        <p14:creationId xmlns:p14="http://schemas.microsoft.com/office/powerpoint/2010/main" val="253780104"/>
-      </p:ext>
-    </p:extLst>
-  </p:cSld>
-  <p:clrMapOvr>
-    <a:masterClrMapping/>
-  </p:clrMapOvr>
-</p:sld>
-</file>
-
-<file path=ppt/slides/slide20.xml><?xml version="1.0" encoding="utf-8"?>
+<file path=ppt/slides/slide21.xml><?xml version="1.0" encoding="utf-8"?>
 <p:sld xmlns:a="http://schemas.openxmlformats.org/drawingml/2006/main" xmlns:r="http://schemas.openxmlformats.org/officeDocument/2006/relationships" xmlns:p="http://schemas.openxmlformats.org/presentationml/2006/main">
   <p:cSld>
     <p:bg>
@@ -15844,11 +17217,19 @@
             </a:r>
             <a:r>
               <a:rPr lang="fr-FR" dirty="0"/>
-              <a:t>  UNIQUEMENT pour les </a:t>
-            </a:r>
-            <a:r>
-              <a:rPr lang="fr-FR"/>
-              <a:t>transactions frauduleuses</a:t>
+              <a:t>  UNIQUEMENT pour les transactions </a:t>
+            </a:r>
+            <a:r>
+              <a:rPr lang="fr-FR" dirty="0" err="1"/>
+              <a:t>frauduleusesgit</a:t>
+            </a:r>
+            <a:r>
+              <a:rPr lang="fr-FR" dirty="0"/>
+              <a:t> </a:t>
+            </a:r>
+            <a:r>
+              <a:rPr lang="fr-FR" dirty="0" err="1"/>
+              <a:t>status</a:t>
             </a:r>
             <a:endParaRPr lang="fr-FR" dirty="0"/>
           </a:p>

</xml_diff>